<commit_message>
Bret: Committed presentation and milestone 6 plans - v2
</commit_message>
<xml_diff>
--- a/docs/presentations/Garden_Explore_Plan.pptx
+++ b/docs/presentations/Garden_Explore_Plan.pptx
@@ -4918,7 +4918,7 @@
         </p:nvSpPr>
         <p:spPr>
           <a:xfrm>
-            <a:off x="1060704" y="3712464"/>
+            <a:off x="786384" y="3712464"/>
             <a:ext cx="256032" cy="256032"/>
           </a:xfrm>
           <a:prstGeom prst="ellipse">
@@ -4943,7 +4943,7 @@
         </p:nvSpPr>
         <p:spPr>
           <a:xfrm>
-            <a:off x="640080" y="2971800"/>
+            <a:off x="365760" y="2971800"/>
             <a:ext cx="1097280" cy="365760"/>
           </a:xfrm>
           <a:prstGeom prst="rect">
@@ -4982,7 +4982,7 @@
         </p:nvSpPr>
         <p:spPr>
           <a:xfrm>
-            <a:off x="365760" y="4160520"/>
+            <a:off x="91440" y="4160520"/>
             <a:ext cx="1645920" cy="640080"/>
           </a:xfrm>
           <a:prstGeom prst="rect">
@@ -5021,7 +5021,7 @@
         </p:nvSpPr>
         <p:spPr>
           <a:xfrm>
-            <a:off x="365760" y="4800600"/>
+            <a:off x="91440" y="4800600"/>
             <a:ext cx="1645920" cy="274320"/>
           </a:xfrm>
           <a:prstGeom prst="rect">
@@ -5060,7 +5060,7 @@
         </p:nvSpPr>
         <p:spPr>
           <a:xfrm>
-            <a:off x="2157984" y="3712464"/>
+            <a:off x="1883664" y="3712464"/>
             <a:ext cx="256032" cy="256032"/>
           </a:xfrm>
           <a:prstGeom prst="ellipse">
@@ -5085,7 +5085,7 @@
         </p:nvSpPr>
         <p:spPr>
           <a:xfrm>
-            <a:off x="1737360" y="2971800"/>
+            <a:off x="1463040" y="2971800"/>
             <a:ext cx="1097280" cy="365760"/>
           </a:xfrm>
           <a:prstGeom prst="rect">
@@ -5124,7 +5124,7 @@
         </p:nvSpPr>
         <p:spPr>
           <a:xfrm>
-            <a:off x="1463040" y="4160520"/>
+            <a:off x="1188720" y="4160520"/>
             <a:ext cx="1645920" cy="640080"/>
           </a:xfrm>
           <a:prstGeom prst="rect">
@@ -5163,7 +5163,7 @@
         </p:nvSpPr>
         <p:spPr>
           <a:xfrm>
-            <a:off x="1463040" y="4800600"/>
+            <a:off x="1188720" y="4800600"/>
             <a:ext cx="1645920" cy="274320"/>
           </a:xfrm>
           <a:prstGeom prst="rect">
@@ -5202,7 +5202,7 @@
         </p:nvSpPr>
         <p:spPr>
           <a:xfrm>
-            <a:off x="3255264" y="3712464"/>
+            <a:off x="2980944" y="3712464"/>
             <a:ext cx="256032" cy="256032"/>
           </a:xfrm>
           <a:prstGeom prst="ellipse">
@@ -5227,7 +5227,7 @@
         </p:nvSpPr>
         <p:spPr>
           <a:xfrm>
-            <a:off x="2834640" y="2971800"/>
+            <a:off x="2560320" y="2971800"/>
             <a:ext cx="1097280" cy="365760"/>
           </a:xfrm>
           <a:prstGeom prst="rect">
@@ -5266,7 +5266,7 @@
         </p:nvSpPr>
         <p:spPr>
           <a:xfrm>
-            <a:off x="2560320" y="4160520"/>
+            <a:off x="2286000" y="4160520"/>
             <a:ext cx="1645920" cy="640080"/>
           </a:xfrm>
           <a:prstGeom prst="rect">
@@ -5305,7 +5305,7 @@
         </p:nvSpPr>
         <p:spPr>
           <a:xfrm>
-            <a:off x="2560320" y="4800600"/>
+            <a:off x="2286000" y="4800600"/>
             <a:ext cx="1645920" cy="274320"/>
           </a:xfrm>
           <a:prstGeom prst="rect">
@@ -5344,7 +5344,7 @@
         </p:nvSpPr>
         <p:spPr>
           <a:xfrm>
-            <a:off x="4535424" y="3712464"/>
+            <a:off x="3986784" y="3712464"/>
             <a:ext cx="256032" cy="256032"/>
           </a:xfrm>
           <a:prstGeom prst="ellipse">
@@ -5369,7 +5369,7 @@
         </p:nvSpPr>
         <p:spPr>
           <a:xfrm>
-            <a:off x="4114800" y="2971800"/>
+            <a:off x="3566160" y="2971800"/>
             <a:ext cx="1097280" cy="365760"/>
           </a:xfrm>
           <a:prstGeom prst="rect">
@@ -5394,6 +5394,165 @@
                 <a:ea typeface="Georgia" pitchFamily="34" charset="-122"/>
                 <a:cs typeface="Georgia" pitchFamily="34" charset="-120"/>
               </a:rPr>
+              <a:t>M3</a:t>
+            </a:r>
+            <a:endParaRPr lang="en-US" sz="1600" dirty="0"/>
+          </a:p>
+        </p:txBody>
+      </p:sp>
+      <p:sp>
+        <p:nvSpPr>
+          <p:cNvPr id="27" name="Text 25"/>
+          <p:cNvSpPr/>
+          <p:nvPr/>
+        </p:nvSpPr>
+        <p:spPr>
+          <a:xfrm>
+            <a:off x="3291840" y="4160520"/>
+            <a:ext cx="1645920" cy="640080"/>
+          </a:xfrm>
+          <a:prstGeom prst="rect">
+            <a:avLst/>
+          </a:prstGeom>
+          <a:noFill/>
+          <a:ln/>
+        </p:spPr>
+        <p:txBody>
+          <a:bodyPr wrap="square" lIns="0" tIns="0" rIns="0" bIns="0" rtlCol="0" anchor="ctr"/>
+          <a:lstStyle/>
+          <a:p>
+            <a:pPr algn="ctr" indent="0" marL="0">
+              <a:buNone/>
+            </a:pPr>
+            <a:r>
+              <a:rPr lang="en-US" sz="1100" dirty="0">
+                <a:solidFill>
+                  <a:srgbClr val="1A2B19"/>
+                </a:solidFill>
+                <a:latin typeface="Calibri" pitchFamily="34" charset="0"/>
+                <a:ea typeface="Calibri" pitchFamily="34" charset="-122"/>
+                <a:cs typeface="Calibri" pitchFamily="34" charset="-120"/>
+              </a:rPr>
+              <a:t>Self-hosted</a:t>
+            </a:r>
+            <a:endParaRPr lang="en-US" sz="1100" dirty="0"/>
+          </a:p>
+          <a:p>
+            <a:pPr algn="ctr" indent="0" marL="0">
+              <a:buNone/>
+            </a:pPr>
+            <a:r>
+              <a:rPr lang="en-US" sz="1100" dirty="0">
+                <a:solidFill>
+                  <a:srgbClr val="1A2B19"/>
+                </a:solidFill>
+                <a:latin typeface="Calibri" pitchFamily="34" charset="0"/>
+                <a:ea typeface="Calibri" pitchFamily="34" charset="-122"/>
+                <a:cs typeface="Calibri" pitchFamily="34" charset="-120"/>
+              </a:rPr>
+              <a:t>deployment</a:t>
+            </a:r>
+            <a:endParaRPr lang="en-US" sz="1100" dirty="0"/>
+          </a:p>
+        </p:txBody>
+      </p:sp>
+      <p:sp>
+        <p:nvSpPr>
+          <p:cNvPr id="28" name="Text 26"/>
+          <p:cNvSpPr/>
+          <p:nvPr/>
+        </p:nvSpPr>
+        <p:spPr>
+          <a:xfrm>
+            <a:off x="3291840" y="4800600"/>
+            <a:ext cx="1645920" cy="274320"/>
+          </a:xfrm>
+          <a:prstGeom prst="rect">
+            <a:avLst/>
+          </a:prstGeom>
+          <a:noFill/>
+          <a:ln/>
+        </p:spPr>
+        <p:txBody>
+          <a:bodyPr wrap="square" lIns="0" tIns="0" rIns="0" bIns="0" rtlCol="0" anchor="ctr"/>
+          <a:lstStyle/>
+          <a:p>
+            <a:pPr algn="ctr" indent="0" marL="0">
+              <a:buNone/>
+            </a:pPr>
+            <a:r>
+              <a:rPr lang="en-US" sz="1000" i="1" dirty="0">
+                <a:solidFill>
+                  <a:srgbClr val="6B7B68"/>
+                </a:solidFill>
+                <a:latin typeface="Calibri" pitchFamily="34" charset="0"/>
+                <a:ea typeface="Calibri" pitchFamily="34" charset="-122"/>
+                <a:cs typeface="Calibri" pitchFamily="34" charset="-120"/>
+              </a:rPr>
+              <a:t>early May</a:t>
+            </a:r>
+            <a:endParaRPr lang="en-US" sz="1000" dirty="0"/>
+          </a:p>
+        </p:txBody>
+      </p:sp>
+      <p:sp>
+        <p:nvSpPr>
+          <p:cNvPr id="29" name="Shape 27"/>
+          <p:cNvSpPr/>
+          <p:nvPr/>
+        </p:nvSpPr>
+        <p:spPr>
+          <a:xfrm>
+            <a:off x="5084064" y="3712464"/>
+            <a:ext cx="256032" cy="256032"/>
+          </a:xfrm>
+          <a:prstGeom prst="ellipse">
+            <a:avLst/>
+          </a:prstGeom>
+          <a:solidFill>
+            <a:srgbClr val="2D4A2B"/>
+          </a:solidFill>
+          <a:ln w="12700">
+            <a:solidFill>
+              <a:srgbClr val="2D4A2B"/>
+            </a:solidFill>
+            <a:prstDash val="solid"/>
+          </a:ln>
+        </p:spPr>
+      </p:sp>
+      <p:sp>
+        <p:nvSpPr>
+          <p:cNvPr id="30" name="Text 28"/>
+          <p:cNvSpPr/>
+          <p:nvPr/>
+        </p:nvSpPr>
+        <p:spPr>
+          <a:xfrm>
+            <a:off x="4663440" y="2971800"/>
+            <a:ext cx="1097280" cy="365760"/>
+          </a:xfrm>
+          <a:prstGeom prst="rect">
+            <a:avLst/>
+          </a:prstGeom>
+          <a:noFill/>
+          <a:ln/>
+        </p:spPr>
+        <p:txBody>
+          <a:bodyPr wrap="square" lIns="0" tIns="0" rIns="0" bIns="0" rtlCol="0" anchor="ctr"/>
+          <a:lstStyle/>
+          <a:p>
+            <a:pPr algn="ctr" indent="0" marL="0">
+              <a:buNone/>
+            </a:pPr>
+            <a:r>
+              <a:rPr lang="en-US" sz="1600" b="1" dirty="0">
+                <a:solidFill>
+                  <a:srgbClr val="1A2B19"/>
+                </a:solidFill>
+                <a:latin typeface="Georgia" pitchFamily="34" charset="0"/>
+                <a:ea typeface="Georgia" pitchFamily="34" charset="-122"/>
+                <a:cs typeface="Georgia" pitchFamily="34" charset="-120"/>
+              </a:rPr>
               <a:t>M4</a:t>
             </a:r>
             <a:endParaRPr lang="en-US" sz="1600" dirty="0"/>
@@ -5402,13 +5561,13 @@
       </p:sp>
       <p:sp>
         <p:nvSpPr>
-          <p:cNvPr id="27" name="Text 25"/>
-          <p:cNvSpPr/>
-          <p:nvPr/>
-        </p:nvSpPr>
-        <p:spPr>
-          <a:xfrm>
-            <a:off x="3840480" y="4160520"/>
+          <p:cNvPr id="31" name="Text 29"/>
+          <p:cNvSpPr/>
+          <p:nvPr/>
+        </p:nvSpPr>
+        <p:spPr>
+          <a:xfrm>
+            <a:off x="4389120" y="4160520"/>
             <a:ext cx="1645920" cy="640080"/>
           </a:xfrm>
           <a:prstGeom prst="rect">
@@ -5458,13 +5617,13 @@
       </p:sp>
       <p:sp>
         <p:nvSpPr>
-          <p:cNvPr id="28" name="Text 26"/>
-          <p:cNvSpPr/>
-          <p:nvPr/>
-        </p:nvSpPr>
-        <p:spPr>
-          <a:xfrm>
-            <a:off x="3840480" y="4800600"/>
+          <p:cNvPr id="32" name="Text 30"/>
+          <p:cNvSpPr/>
+          <p:nvPr/>
+        </p:nvSpPr>
+        <p:spPr>
+          <a:xfrm>
+            <a:off x="4389120" y="4800600"/>
             <a:ext cx="1645920" cy="274320"/>
           </a:xfrm>
           <a:prstGeom prst="rect">
@@ -5497,13 +5656,13 @@
       </p:sp>
       <p:sp>
         <p:nvSpPr>
-          <p:cNvPr id="29" name="Shape 27"/>
-          <p:cNvSpPr/>
-          <p:nvPr/>
-        </p:nvSpPr>
-        <p:spPr>
-          <a:xfrm>
-            <a:off x="5779008" y="3675888"/>
+          <p:cNvPr id="33" name="Shape 31"/>
+          <p:cNvSpPr/>
+          <p:nvPr/>
+        </p:nvSpPr>
+        <p:spPr>
+          <a:xfrm>
+            <a:off x="6144768" y="3675888"/>
             <a:ext cx="329184" cy="329184"/>
           </a:xfrm>
           <a:prstGeom prst="ellipse">
@@ -5522,13 +5681,13 @@
       </p:sp>
       <p:sp>
         <p:nvSpPr>
-          <p:cNvPr id="30" name="Text 28"/>
-          <p:cNvSpPr/>
-          <p:nvPr/>
-        </p:nvSpPr>
-        <p:spPr>
-          <a:xfrm>
-            <a:off x="5394960" y="2971800"/>
+          <p:cNvPr id="34" name="Text 32"/>
+          <p:cNvSpPr/>
+          <p:nvPr/>
+        </p:nvSpPr>
+        <p:spPr>
+          <a:xfrm>
+            <a:off x="5760720" y="2971800"/>
             <a:ext cx="1097280" cy="365760"/>
           </a:xfrm>
           <a:prstGeom prst="rect">
@@ -5561,13 +5720,13 @@
       </p:sp>
       <p:sp>
         <p:nvSpPr>
-          <p:cNvPr id="31" name="Text 29"/>
-          <p:cNvSpPr/>
-          <p:nvPr/>
-        </p:nvSpPr>
-        <p:spPr>
-          <a:xfrm>
-            <a:off x="5120640" y="4160520"/>
+          <p:cNvPr id="35" name="Text 33"/>
+          <p:cNvSpPr/>
+          <p:nvPr/>
+        </p:nvSpPr>
+        <p:spPr>
+          <a:xfrm>
+            <a:off x="5486400" y="4160520"/>
             <a:ext cx="1645920" cy="640080"/>
           </a:xfrm>
           <a:prstGeom prst="rect">
@@ -5600,13 +5759,13 @@
       </p:sp>
       <p:sp>
         <p:nvSpPr>
-          <p:cNvPr id="32" name="Text 30"/>
-          <p:cNvSpPr/>
-          <p:nvPr/>
-        </p:nvSpPr>
-        <p:spPr>
-          <a:xfrm>
-            <a:off x="5120640" y="4800600"/>
+          <p:cNvPr id="36" name="Text 34"/>
+          <p:cNvSpPr/>
+          <p:nvPr/>
+        </p:nvSpPr>
+        <p:spPr>
+          <a:xfrm>
+            <a:off x="5486400" y="4800600"/>
             <a:ext cx="1645920" cy="274320"/>
           </a:xfrm>
           <a:prstGeom prst="rect">
@@ -5639,13 +5798,13 @@
       </p:sp>
       <p:sp>
         <p:nvSpPr>
-          <p:cNvPr id="33" name="Shape 31"/>
-          <p:cNvSpPr/>
-          <p:nvPr/>
-        </p:nvSpPr>
-        <p:spPr>
-          <a:xfrm>
-            <a:off x="7680960" y="3657600"/>
+          <p:cNvPr id="37" name="Shape 35"/>
+          <p:cNvSpPr/>
+          <p:nvPr/>
+        </p:nvSpPr>
+        <p:spPr>
+          <a:xfrm>
+            <a:off x="7863840" y="3657600"/>
             <a:ext cx="365760" cy="365760"/>
           </a:xfrm>
           <a:prstGeom prst="ellipse">
@@ -5664,13 +5823,13 @@
       </p:sp>
       <p:sp>
         <p:nvSpPr>
-          <p:cNvPr id="34" name="Text 32"/>
-          <p:cNvSpPr/>
-          <p:nvPr/>
-        </p:nvSpPr>
-        <p:spPr>
-          <a:xfrm>
-            <a:off x="7315200" y="2971800"/>
+          <p:cNvPr id="38" name="Text 36"/>
+          <p:cNvSpPr/>
+          <p:nvPr/>
+        </p:nvSpPr>
+        <p:spPr>
+          <a:xfrm>
+            <a:off x="7498080" y="2971800"/>
             <a:ext cx="1097280" cy="365760"/>
           </a:xfrm>
           <a:prstGeom prst="rect">
@@ -5703,13 +5862,13 @@
       </p:sp>
       <p:sp>
         <p:nvSpPr>
-          <p:cNvPr id="35" name="Text 33"/>
-          <p:cNvSpPr/>
-          <p:nvPr/>
-        </p:nvSpPr>
-        <p:spPr>
-          <a:xfrm>
-            <a:off x="7040880" y="4160520"/>
+          <p:cNvPr id="39" name="Text 37"/>
+          <p:cNvSpPr/>
+          <p:nvPr/>
+        </p:nvSpPr>
+        <p:spPr>
+          <a:xfrm>
+            <a:off x="7223760" y="4160520"/>
             <a:ext cx="1645920" cy="640080"/>
           </a:xfrm>
           <a:prstGeom prst="rect">
@@ -5759,13 +5918,13 @@
       </p:sp>
       <p:sp>
         <p:nvSpPr>
-          <p:cNvPr id="36" name="Text 34"/>
-          <p:cNvSpPr/>
-          <p:nvPr/>
-        </p:nvSpPr>
-        <p:spPr>
-          <a:xfrm>
-            <a:off x="7040880" y="4800600"/>
+          <p:cNvPr id="40" name="Text 38"/>
+          <p:cNvSpPr/>
+          <p:nvPr/>
+        </p:nvSpPr>
+        <p:spPr>
+          <a:xfrm>
+            <a:off x="7223760" y="4800600"/>
             <a:ext cx="1645920" cy="274320"/>
           </a:xfrm>
           <a:prstGeom prst="rect">
@@ -5798,7 +5957,7 @@
       </p:sp>
       <p:sp>
         <p:nvSpPr>
-          <p:cNvPr id="37" name="Shape 35"/>
+          <p:cNvPr id="41" name="Shape 39"/>
           <p:cNvSpPr/>
           <p:nvPr/>
         </p:nvSpPr>
@@ -5823,7 +5982,7 @@
       </p:sp>
       <p:sp>
         <p:nvSpPr>
-          <p:cNvPr id="38" name="Text 36"/>
+          <p:cNvPr id="42" name="Text 40"/>
           <p:cNvSpPr/>
           <p:nvPr/>
         </p:nvSpPr>
@@ -5862,7 +6021,7 @@
       </p:sp>
       <p:sp>
         <p:nvSpPr>
-          <p:cNvPr id="39" name="Text 37"/>
+          <p:cNvPr id="43" name="Text 41"/>
           <p:cNvSpPr/>
           <p:nvPr/>
         </p:nvSpPr>
@@ -5901,7 +6060,7 @@
       </p:sp>
       <p:sp>
         <p:nvSpPr>
-          <p:cNvPr id="40" name="Text 38"/>
+          <p:cNvPr id="44" name="Text 42"/>
           <p:cNvSpPr/>
           <p:nvPr/>
         </p:nvSpPr>
@@ -5940,7 +6099,7 @@
       </p:sp>
       <p:sp>
         <p:nvSpPr>
-          <p:cNvPr id="41" name="Shape 39"/>
+          <p:cNvPr id="45" name="Shape 43"/>
           <p:cNvSpPr/>
           <p:nvPr/>
         </p:nvSpPr>
@@ -5965,7 +6124,7 @@
       </p:sp>
       <p:sp>
         <p:nvSpPr>
-          <p:cNvPr id="42" name="Text 40"/>
+          <p:cNvPr id="46" name="Text 44"/>
           <p:cNvSpPr/>
           <p:nvPr/>
         </p:nvSpPr>
@@ -6004,7 +6163,7 @@
       </p:sp>
       <p:sp>
         <p:nvSpPr>
-          <p:cNvPr id="43" name="Text 41"/>
+          <p:cNvPr id="47" name="Text 45"/>
           <p:cNvSpPr/>
           <p:nvPr/>
         </p:nvSpPr>
@@ -6043,7 +6202,7 @@
       </p:sp>
       <p:sp>
         <p:nvSpPr>
-          <p:cNvPr id="44" name="Text 42"/>
+          <p:cNvPr id="48" name="Text 46"/>
           <p:cNvSpPr/>
           <p:nvPr/>
         </p:nvSpPr>
@@ -6077,45 +6236,6 @@
               <a:t>future</a:t>
             </a:r>
             <a:endParaRPr lang="en-US" sz="1000" dirty="0"/>
-          </a:p>
-        </p:txBody>
-      </p:sp>
-      <p:sp>
-        <p:nvSpPr>
-          <p:cNvPr id="45" name="Text 43"/>
-          <p:cNvSpPr/>
-          <p:nvPr/>
-        </p:nvSpPr>
-        <p:spPr>
-          <a:xfrm>
-            <a:off x="731520" y="6035040"/>
-            <a:ext cx="10972800" cy="274320"/>
-          </a:xfrm>
-          <a:prstGeom prst="rect">
-            <a:avLst/>
-          </a:prstGeom>
-          <a:noFill/>
-          <a:ln/>
-        </p:spPr>
-        <p:txBody>
-          <a:bodyPr wrap="square" lIns="0" tIns="0" rIns="0" bIns="0" rtlCol="0" anchor="ctr"/>
-          <a:lstStyle/>
-          <a:p>
-            <a:pPr algn="l" indent="0" marL="0">
-              <a:buNone/>
-            </a:pPr>
-            <a:r>
-              <a:rPr lang="en-US" sz="1100" i="1" dirty="0">
-                <a:solidFill>
-                  <a:srgbClr val="6B7B68"/>
-                </a:solidFill>
-                <a:latin typeface="Calibri" pitchFamily="34" charset="0"/>
-                <a:ea typeface="Calibri" pitchFamily="34" charset="-122"/>
-                <a:cs typeface="Calibri" pitchFamily="34" charset="-120"/>
-              </a:rPr>
-              <a:t>Milestone 3 (self-hosted deployment via Docker Compose) deferred — the project shipped on Cloud Run instead.</a:t>
-            </a:r>
-            <a:endParaRPr lang="en-US" sz="1100" dirty="0"/>
           </a:p>
         </p:txBody>
       </p:sp>

</xml_diff>

<commit_message>
Bret: Committed presentation and milestone 6 plans - v3
</commit_message>
<xml_diff>
--- a/docs/presentations/Garden_Explore_Plan.pptx
+++ b/docs/presentations/Garden_Explore_Plan.pptx
@@ -17,9 +17,10 @@
     <p:sldId id="265" r:id="rId11"/>
     <p:sldId id="266" r:id="rId12"/>
     <p:sldId id="267" r:id="rId13"/>
+    <p:sldId id="268" r:id="rId14"/>
   </p:sldIdLst>
   <p:notesMasterIdLst>
-    <p:notesMasterId r:id="rId14"/>
+    <p:notesMasterId r:id="rId15"/>
   </p:notesMasterIdLst>
   <p:sldSz cx="12192000" cy="6858000"/>
   <p:notesSz cx="6858000" cy="12192000"/>
@@ -801,6 +802,94 @@
             <a:fld id="{F7021451-1387-4CA6-816F-3879F97B5CBC}" type="slidenum">
               <a:rPr lang="en-US"/>
               <a:t>12</a:t>
+            </a:fld>
+            <a:endParaRPr lang="en-US"/>
+          </a:p>
+        </p:txBody>
+      </p:sp>
+    </p:spTree>
+    <p:extLst>
+      <p:ext uri="{BB962C8B-B14F-4D97-AF65-F5344CB8AC3E}">
+        <p14:creationId xmlns:p14="http://schemas.microsoft.com/office/powerpoint/2010/main" val="1024086991"/>
+      </p:ext>
+    </p:extLst>
+  </p:cSld>
+  <p:clrMapOvr>
+    <a:masterClrMapping/>
+  </p:clrMapOvr>
+</p:notes>
+</file>
+
+<file path=ppt/notesSlides/notesSlide13.xml><?xml version="1.0" encoding="utf-8"?>
+<p:notes xmlns:a="http://schemas.openxmlformats.org/drawingml/2006/main" xmlns:r="http://schemas.openxmlformats.org/officeDocument/2006/relationships" xmlns:p="http://schemas.openxmlformats.org/presentationml/2006/main">
+  <p:cSld>
+    <p:spTree>
+      <p:nvGrpSpPr>
+        <p:cNvPr id="1" name=""/>
+        <p:cNvGrpSpPr/>
+        <p:nvPr/>
+      </p:nvGrpSpPr>
+      <p:grpSpPr>
+        <a:xfrm>
+          <a:off x="0" y="0"/>
+          <a:ext cx="0" cy="0"/>
+          <a:chOff x="0" y="0"/>
+          <a:chExt cx="0" cy="0"/>
+        </a:xfrm>
+      </p:grpSpPr>
+      <p:sp>
+        <p:nvSpPr>
+          <p:cNvPr id="2" name="Slide Image Placeholder 1"/>
+          <p:cNvSpPr>
+            <a:spLocks noGrp="1" noRot="1" noChangeAspect="1"/>
+          </p:cNvSpPr>
+          <p:nvPr>
+            <p:ph type="sldImg"/>
+          </p:nvPr>
+        </p:nvSpPr>
+        <p:spPr/>
+      </p:sp>
+      <p:sp>
+        <p:nvSpPr>
+          <p:cNvPr id="3" name="Notes Placeholder 2"/>
+          <p:cNvSpPr>
+            <a:spLocks noGrp="1"/>
+          </p:cNvSpPr>
+          <p:nvPr>
+            <p:ph type="body" idx="1"/>
+          </p:nvPr>
+        </p:nvSpPr>
+        <p:spPr/>
+        <p:txBody>
+          <a:bodyPr/>
+          <a:lstStyle/>
+          <a:p>
+            <a:r>
+              <a:rPr lang="en-US" dirty="0"/>
+              <a:t/>
+            </a:r>
+            <a:endParaRPr lang="en-US" dirty="0"/>
+          </a:p>
+        </p:txBody>
+      </p:sp>
+      <p:sp>
+        <p:nvSpPr>
+          <p:cNvPr id="4" name="Slide Number Placeholder 3"/>
+          <p:cNvSpPr>
+            <a:spLocks noGrp="1"/>
+          </p:cNvSpPr>
+          <p:nvPr>
+            <p:ph type="sldNum" sz="quarter" idx="10"/>
+          </p:nvPr>
+        </p:nvSpPr>
+        <p:spPr/>
+        <p:txBody>
+          <a:bodyPr/>
+          <a:lstStyle/>
+          <a:p>
+            <a:fld id="{F7021451-1387-4CA6-816F-3879F97B5CBC}" type="slidenum">
+              <a:rPr lang="en-US"/>
+              <a:t>13</a:t>
             </a:fld>
             <a:endParaRPr lang="en-US"/>
           </a:p>
@@ -2114,7 +2203,7 @@
                 <a:ea typeface="Georgia" pitchFamily="34" charset="-122"/>
                 <a:cs typeface="Georgia" pitchFamily="34" charset="-120"/>
               </a:rPr>
-              <a:t>Dependencies and parallel work</a:t>
+              <a:t>Sequence and dependencies</a:t>
             </a:r>
             <a:endParaRPr lang="en-US" sz="3600" dirty="0"/>
           </a:p>
@@ -2153,7 +2242,7 @@
                 <a:ea typeface="Calibri" pitchFamily="34" charset="-122"/>
                 <a:cs typeface="Calibri" pitchFamily="34" charset="-120"/>
               </a:rPr>
-              <a:t>What can run in parallel; what must run in order.</a:t>
+              <a:t>What blocks what, and what can run any time.</a:t>
             </a:r>
             <a:endParaRPr lang="en-US" sz="1600" dirty="0"/>
           </a:p>
@@ -2167,8 +2256,97 @@
         </p:nvSpPr>
         <p:spPr>
           <a:xfrm>
-            <a:off x="2194560" y="1737360"/>
-            <a:ext cx="1630680" cy="274320"/>
+            <a:off x="731520" y="2103120"/>
+            <a:ext cx="3657600" cy="274320"/>
+          </a:xfrm>
+          <a:prstGeom prst="rect">
+            <a:avLst/>
+          </a:prstGeom>
+          <a:noFill/>
+          <a:ln/>
+        </p:spPr>
+        <p:txBody>
+          <a:bodyPr wrap="square" lIns="0" tIns="0" rIns="0" bIns="0" rtlCol="0" anchor="ctr"/>
+          <a:lstStyle/>
+          <a:p>
+            <a:pPr indent="0" marL="0">
+              <a:buNone/>
+            </a:pPr>
+            <a:r>
+              <a:rPr lang="en-US" sz="1000" b="1" spc="600" kern="0" dirty="0">
+                <a:solidFill>
+                  <a:srgbClr val="D4A5A5"/>
+                </a:solidFill>
+                <a:latin typeface="Calibri" pitchFamily="34" charset="0"/>
+                <a:ea typeface="Calibri" pitchFamily="34" charset="-122"/>
+                <a:cs typeface="Calibri" pitchFamily="34" charset="-120"/>
+              </a:rPr>
+              <a:t>INDEPENDENT</a:t>
+            </a:r>
+            <a:endParaRPr lang="en-US" sz="1000" dirty="0"/>
+          </a:p>
+        </p:txBody>
+      </p:sp>
+      <p:sp>
+        <p:nvSpPr>
+          <p:cNvPr id="5" name="Shape 3"/>
+          <p:cNvSpPr/>
+          <p:nvPr/>
+        </p:nvSpPr>
+        <p:spPr>
+          <a:xfrm>
+            <a:off x="731520" y="2423160"/>
+            <a:ext cx="3291840" cy="914400"/>
+          </a:xfrm>
+          <a:prstGeom prst="rect">
+            <a:avLst/>
+          </a:prstGeom>
+          <a:solidFill>
+            <a:srgbClr val="EBE3D0"/>
+          </a:solidFill>
+          <a:ln w="19050">
+            <a:solidFill>
+              <a:srgbClr val="D4A5A5"/>
+            </a:solidFill>
+            <a:prstDash val="solid"/>
+          </a:ln>
+        </p:spPr>
+      </p:sp>
+      <p:sp>
+        <p:nvSpPr>
+          <p:cNvPr id="6" name="Shape 4"/>
+          <p:cNvSpPr/>
+          <p:nvPr/>
+        </p:nvSpPr>
+        <p:spPr>
+          <a:xfrm>
+            <a:off x="914400" y="2606040"/>
+            <a:ext cx="548640" cy="548640"/>
+          </a:xfrm>
+          <a:prstGeom prst="ellipse">
+            <a:avLst/>
+          </a:prstGeom>
+          <a:solidFill>
+            <a:srgbClr val="D4A5A5"/>
+          </a:solidFill>
+          <a:ln w="12700">
+            <a:solidFill>
+              <a:srgbClr val="D4A5A5"/>
+            </a:solidFill>
+            <a:prstDash val="solid"/>
+          </a:ln>
+        </p:spPr>
+      </p:sp>
+      <p:sp>
+        <p:nvSpPr>
+          <p:cNvPr id="7" name="Text 5"/>
+          <p:cNvSpPr/>
+          <p:nvPr/>
+        </p:nvSpPr>
+        <p:spPr>
+          <a:xfrm>
+            <a:off x="914400" y="2606040"/>
+            <a:ext cx="548640" cy="548640"/>
           </a:xfrm>
           <a:prstGeom prst="rect">
             <a:avLst/>
@@ -2184,7 +2362,85 @@
               <a:buNone/>
             </a:pPr>
             <a:r>
-              <a:rPr lang="en-US" sz="1100" b="1" dirty="0">
+              <a:rPr lang="en-US" sz="1800" b="1" dirty="0">
+                <a:solidFill>
+                  <a:srgbClr val="F5EFE0"/>
+                </a:solidFill>
+                <a:latin typeface="Georgia" pitchFamily="34" charset="0"/>
+                <a:ea typeface="Georgia" pitchFamily="34" charset="-122"/>
+                <a:cs typeface="Georgia" pitchFamily="34" charset="-120"/>
+              </a:rPr>
+              <a:t>1</a:t>
+            </a:r>
+            <a:endParaRPr lang="en-US" sz="1800" dirty="0"/>
+          </a:p>
+        </p:txBody>
+      </p:sp>
+      <p:sp>
+        <p:nvSpPr>
+          <p:cNvPr id="8" name="Text 6"/>
+          <p:cNvSpPr/>
+          <p:nvPr/>
+        </p:nvSpPr>
+        <p:spPr>
+          <a:xfrm>
+            <a:off x="1600200" y="2606040"/>
+            <a:ext cx="2286000" cy="274320"/>
+          </a:xfrm>
+          <a:prstGeom prst="rect">
+            <a:avLst/>
+          </a:prstGeom>
+          <a:noFill/>
+          <a:ln/>
+        </p:spPr>
+        <p:txBody>
+          <a:bodyPr wrap="square" lIns="0" tIns="0" rIns="0" bIns="0" rtlCol="0" anchor="ctr"/>
+          <a:lstStyle/>
+          <a:p>
+            <a:pPr indent="0" marL="0">
+              <a:buNone/>
+            </a:pPr>
+            <a:r>
+              <a:rPr lang="en-US" sz="1400" b="1" dirty="0">
+                <a:solidFill>
+                  <a:srgbClr val="2D4A2B"/>
+                </a:solidFill>
+                <a:latin typeface="Calibri" pitchFamily="34" charset="0"/>
+                <a:ea typeface="Calibri" pitchFamily="34" charset="-122"/>
+                <a:cs typeface="Calibri" pitchFamily="34" charset="-120"/>
+              </a:rPr>
+              <a:t>Tools</a:t>
+            </a:r>
+            <a:endParaRPr lang="en-US" sz="1400" dirty="0"/>
+          </a:p>
+        </p:txBody>
+      </p:sp>
+      <p:sp>
+        <p:nvSpPr>
+          <p:cNvPr id="9" name="Text 7"/>
+          <p:cNvSpPr/>
+          <p:nvPr/>
+        </p:nvSpPr>
+        <p:spPr>
+          <a:xfrm>
+            <a:off x="1600200" y="2926080"/>
+            <a:ext cx="2286000" cy="274320"/>
+          </a:xfrm>
+          <a:prstGeom prst="rect">
+            <a:avLst/>
+          </a:prstGeom>
+          <a:noFill/>
+          <a:ln/>
+        </p:spPr>
+        <p:txBody>
+          <a:bodyPr wrap="square" lIns="0" tIns="0" rIns="0" bIns="0" rtlCol="0" anchor="ctr"/>
+          <a:lstStyle/>
+          <a:p>
+            <a:pPr indent="0" marL="0">
+              <a:buNone/>
+            </a:pPr>
+            <a:r>
+              <a:rPr lang="en-US" sz="1100" i="1" dirty="0">
                 <a:solidFill>
                   <a:srgbClr val="6B7B68"/>
                 </a:solidFill>
@@ -2192,7 +2448,7 @@
                 <a:ea typeface="Calibri" pitchFamily="34" charset="-122"/>
                 <a:cs typeface="Calibri" pitchFamily="34" charset="-120"/>
               </a:rPr>
-              <a:t>Week 1</a:t>
+              <a:t>No dependencies. Run any time.</a:t>
             </a:r>
             <a:endParaRPr lang="en-US" sz="1100" dirty="0"/>
           </a:p>
@@ -2200,30 +2456,69 @@
       </p:sp>
       <p:sp>
         <p:nvSpPr>
-          <p:cNvPr id="5" name="Text 3"/>
-          <p:cNvSpPr/>
-          <p:nvPr/>
-        </p:nvSpPr>
-        <p:spPr>
-          <a:xfrm>
-            <a:off x="3825240" y="1737360"/>
-            <a:ext cx="1630680" cy="274320"/>
-          </a:xfrm>
-          <a:prstGeom prst="rect">
-            <a:avLst/>
-          </a:prstGeom>
-          <a:noFill/>
-          <a:ln/>
-        </p:spPr>
-        <p:txBody>
-          <a:bodyPr wrap="square" lIns="0" tIns="0" rIns="0" bIns="0" rtlCol="0" anchor="ctr"/>
-          <a:lstStyle/>
-          <a:p>
-            <a:pPr algn="ctr" indent="0" marL="0">
-              <a:buNone/>
-            </a:pPr>
-            <a:r>
-              <a:rPr lang="en-US" sz="1100" b="1" dirty="0">
+          <p:cNvPr id="10" name="Text 8"/>
+          <p:cNvSpPr/>
+          <p:nvPr/>
+        </p:nvSpPr>
+        <p:spPr>
+          <a:xfrm>
+            <a:off x="4297680" y="2697480"/>
+            <a:ext cx="7315200" cy="365760"/>
+          </a:xfrm>
+          <a:prstGeom prst="rect">
+            <a:avLst/>
+          </a:prstGeom>
+          <a:noFill/>
+          <a:ln/>
+        </p:spPr>
+        <p:txBody>
+          <a:bodyPr wrap="square" lIns="0" tIns="0" rIns="0" bIns="0" rtlCol="0" anchor="ctr"/>
+          <a:lstStyle/>
+          <a:p>
+            <a:pPr indent="0" marL="0">
+              <a:buNone/>
+            </a:pPr>
+            <a:r>
+              <a:rPr lang="en-US" sz="1200" i="1" dirty="0">
+                <a:solidFill>
+                  <a:srgbClr val="D4A5A5"/>
+                </a:solidFill>
+                <a:latin typeface="Calibri" pitchFamily="34" charset="0"/>
+                <a:ea typeface="Calibri" pitchFamily="34" charset="-122"/>
+                <a:cs typeface="Calibri" pitchFamily="34" charset="-120"/>
+              </a:rPr>
+              <a:t>Recommended first — gives a safety net for the rest of the work.</a:t>
+            </a:r>
+            <a:endParaRPr lang="en-US" sz="1200" dirty="0"/>
+          </a:p>
+        </p:txBody>
+      </p:sp>
+      <p:sp>
+        <p:nvSpPr>
+          <p:cNvPr id="11" name="Text 9"/>
+          <p:cNvSpPr/>
+          <p:nvPr/>
+        </p:nvSpPr>
+        <p:spPr>
+          <a:xfrm>
+            <a:off x="731520" y="3840480"/>
+            <a:ext cx="3657600" cy="274320"/>
+          </a:xfrm>
+          <a:prstGeom prst="rect">
+            <a:avLst/>
+          </a:prstGeom>
+          <a:noFill/>
+          <a:ln/>
+        </p:spPr>
+        <p:txBody>
+          <a:bodyPr wrap="square" lIns="0" tIns="0" rIns="0" bIns="0" rtlCol="0" anchor="ctr"/>
+          <a:lstStyle/>
+          <a:p>
+            <a:pPr indent="0" marL="0">
+              <a:buNone/>
+            </a:pPr>
+            <a:r>
+              <a:rPr lang="en-US" sz="1000" b="1" spc="600" kern="0" dirty="0">
                 <a:solidFill>
                   <a:srgbClr val="6B7B68"/>
                 </a:solidFill>
@@ -2231,213 +2526,11 @@
                 <a:ea typeface="Calibri" pitchFamily="34" charset="-122"/>
                 <a:cs typeface="Calibri" pitchFamily="34" charset="-120"/>
               </a:rPr>
-              <a:t>Week 2</a:t>
-            </a:r>
-            <a:endParaRPr lang="en-US" sz="1100" dirty="0"/>
-          </a:p>
-        </p:txBody>
-      </p:sp>
-      <p:sp>
-        <p:nvSpPr>
-          <p:cNvPr id="6" name="Text 4"/>
-          <p:cNvSpPr/>
-          <p:nvPr/>
-        </p:nvSpPr>
-        <p:spPr>
-          <a:xfrm>
-            <a:off x="5455920" y="1737360"/>
-            <a:ext cx="1630680" cy="274320"/>
-          </a:xfrm>
-          <a:prstGeom prst="rect">
-            <a:avLst/>
-          </a:prstGeom>
-          <a:noFill/>
-          <a:ln/>
-        </p:spPr>
-        <p:txBody>
-          <a:bodyPr wrap="square" lIns="0" tIns="0" rIns="0" bIns="0" rtlCol="0" anchor="ctr"/>
-          <a:lstStyle/>
-          <a:p>
-            <a:pPr algn="ctr" indent="0" marL="0">
-              <a:buNone/>
-            </a:pPr>
-            <a:r>
-              <a:rPr lang="en-US" sz="1100" b="1" dirty="0">
-                <a:solidFill>
-                  <a:srgbClr val="6B7B68"/>
-                </a:solidFill>
-                <a:latin typeface="Calibri" pitchFamily="34" charset="0"/>
-                <a:ea typeface="Calibri" pitchFamily="34" charset="-122"/>
-                <a:cs typeface="Calibri" pitchFamily="34" charset="-120"/>
-              </a:rPr>
-              <a:t>Week 3</a:t>
-            </a:r>
-            <a:endParaRPr lang="en-US" sz="1100" dirty="0"/>
-          </a:p>
-        </p:txBody>
-      </p:sp>
-      <p:sp>
-        <p:nvSpPr>
-          <p:cNvPr id="7" name="Text 5"/>
-          <p:cNvSpPr/>
-          <p:nvPr/>
-        </p:nvSpPr>
-        <p:spPr>
-          <a:xfrm>
-            <a:off x="7086600" y="1737360"/>
-            <a:ext cx="1630680" cy="274320"/>
-          </a:xfrm>
-          <a:prstGeom prst="rect">
-            <a:avLst/>
-          </a:prstGeom>
-          <a:noFill/>
-          <a:ln/>
-        </p:spPr>
-        <p:txBody>
-          <a:bodyPr wrap="square" lIns="0" tIns="0" rIns="0" bIns="0" rtlCol="0" anchor="ctr"/>
-          <a:lstStyle/>
-          <a:p>
-            <a:pPr algn="ctr" indent="0" marL="0">
-              <a:buNone/>
-            </a:pPr>
-            <a:r>
-              <a:rPr lang="en-US" sz="1100" b="1" dirty="0">
-                <a:solidFill>
-                  <a:srgbClr val="6B7B68"/>
-                </a:solidFill>
-                <a:latin typeface="Calibri" pitchFamily="34" charset="0"/>
-                <a:ea typeface="Calibri" pitchFamily="34" charset="-122"/>
-                <a:cs typeface="Calibri" pitchFamily="34" charset="-120"/>
-              </a:rPr>
-              <a:t>Week 4</a:t>
-            </a:r>
-            <a:endParaRPr lang="en-US" sz="1100" dirty="0"/>
-          </a:p>
-        </p:txBody>
-      </p:sp>
-      <p:sp>
-        <p:nvSpPr>
-          <p:cNvPr id="8" name="Text 6"/>
-          <p:cNvSpPr/>
-          <p:nvPr/>
-        </p:nvSpPr>
-        <p:spPr>
-          <a:xfrm>
-            <a:off x="8717280" y="1737360"/>
-            <a:ext cx="1630680" cy="274320"/>
-          </a:xfrm>
-          <a:prstGeom prst="rect">
-            <a:avLst/>
-          </a:prstGeom>
-          <a:noFill/>
-          <a:ln/>
-        </p:spPr>
-        <p:txBody>
-          <a:bodyPr wrap="square" lIns="0" tIns="0" rIns="0" bIns="0" rtlCol="0" anchor="ctr"/>
-          <a:lstStyle/>
-          <a:p>
-            <a:pPr algn="ctr" indent="0" marL="0">
-              <a:buNone/>
-            </a:pPr>
-            <a:r>
-              <a:rPr lang="en-US" sz="1100" b="1" dirty="0">
-                <a:solidFill>
-                  <a:srgbClr val="6B7B68"/>
-                </a:solidFill>
-                <a:latin typeface="Calibri" pitchFamily="34" charset="0"/>
-                <a:ea typeface="Calibri" pitchFamily="34" charset="-122"/>
-                <a:cs typeface="Calibri" pitchFamily="34" charset="-120"/>
-              </a:rPr>
-              <a:t>Week 5</a:t>
-            </a:r>
-            <a:endParaRPr lang="en-US" sz="1100" dirty="0"/>
-          </a:p>
-        </p:txBody>
-      </p:sp>
-      <p:sp>
-        <p:nvSpPr>
-          <p:cNvPr id="9" name="Text 7"/>
-          <p:cNvSpPr/>
-          <p:nvPr/>
-        </p:nvSpPr>
-        <p:spPr>
-          <a:xfrm>
-            <a:off x="10347960" y="1737360"/>
-            <a:ext cx="1630680" cy="274320"/>
-          </a:xfrm>
-          <a:prstGeom prst="rect">
-            <a:avLst/>
-          </a:prstGeom>
-          <a:noFill/>
-          <a:ln/>
-        </p:spPr>
-        <p:txBody>
-          <a:bodyPr wrap="square" lIns="0" tIns="0" rIns="0" bIns="0" rtlCol="0" anchor="ctr"/>
-          <a:lstStyle/>
-          <a:p>
-            <a:pPr algn="ctr" indent="0" marL="0">
-              <a:buNone/>
-            </a:pPr>
-            <a:r>
-              <a:rPr lang="en-US" sz="1100" b="1" dirty="0">
-                <a:solidFill>
-                  <a:srgbClr val="6B7B68"/>
-                </a:solidFill>
-                <a:latin typeface="Calibri" pitchFamily="34" charset="0"/>
-                <a:ea typeface="Calibri" pitchFamily="34" charset="-122"/>
-                <a:cs typeface="Calibri" pitchFamily="34" charset="-120"/>
-              </a:rPr>
-              <a:t>Week 6</a:t>
-            </a:r>
-            <a:endParaRPr lang="en-US" sz="1100" dirty="0"/>
-          </a:p>
-        </p:txBody>
-      </p:sp>
-      <p:sp>
-        <p:nvSpPr>
-          <p:cNvPr id="10" name="Shape 8"/>
-          <p:cNvSpPr/>
-          <p:nvPr/>
-        </p:nvSpPr>
-        <p:spPr>
-          <a:xfrm>
-            <a:off x="2194560" y="2103120"/>
-            <a:ext cx="0" cy="2606040"/>
-          </a:xfrm>
-          <a:prstGeom prst="line">
-            <a:avLst/>
-          </a:prstGeom>
-          <a:noFill/>
-          <a:ln w="6350">
-            <a:solidFill>
-              <a:srgbClr val="6B7B68"/>
-            </a:solidFill>
-            <a:prstDash val="dash"/>
-          </a:ln>
-        </p:spPr>
-      </p:sp>
-      <p:sp>
-        <p:nvSpPr>
-          <p:cNvPr id="11" name="Shape 9"/>
-          <p:cNvSpPr/>
-          <p:nvPr/>
-        </p:nvSpPr>
-        <p:spPr>
-          <a:xfrm>
-            <a:off x="3825240" y="2103120"/>
-            <a:ext cx="0" cy="2606040"/>
-          </a:xfrm>
-          <a:prstGeom prst="line">
-            <a:avLst/>
-          </a:prstGeom>
-          <a:noFill/>
-          <a:ln w="6350">
-            <a:solidFill>
-              <a:srgbClr val="6B7B68"/>
-            </a:solidFill>
-            <a:prstDash val="dash"/>
-          </a:ln>
-        </p:spPr>
+              <a:t>SEQUENTIAL</a:t>
+            </a:r>
+            <a:endParaRPr lang="en-US" sz="1000" dirty="0"/>
+          </a:p>
+        </p:txBody>
       </p:sp>
       <p:sp>
         <p:nvSpPr>
@@ -2447,162 +2540,8 @@
         </p:nvSpPr>
         <p:spPr>
           <a:xfrm>
-            <a:off x="5455920" y="2103120"/>
-            <a:ext cx="0" cy="2606040"/>
-          </a:xfrm>
-          <a:prstGeom prst="line">
-            <a:avLst/>
-          </a:prstGeom>
-          <a:noFill/>
-          <a:ln w="6350">
-            <a:solidFill>
-              <a:srgbClr val="6B7B68"/>
-            </a:solidFill>
-            <a:prstDash val="dash"/>
-          </a:ln>
-        </p:spPr>
-      </p:sp>
-      <p:sp>
-        <p:nvSpPr>
-          <p:cNvPr id="13" name="Shape 11"/>
-          <p:cNvSpPr/>
-          <p:nvPr/>
-        </p:nvSpPr>
-        <p:spPr>
-          <a:xfrm>
-            <a:off x="7086600" y="2103120"/>
-            <a:ext cx="0" cy="2606040"/>
-          </a:xfrm>
-          <a:prstGeom prst="line">
-            <a:avLst/>
-          </a:prstGeom>
-          <a:noFill/>
-          <a:ln w="6350">
-            <a:solidFill>
-              <a:srgbClr val="6B7B68"/>
-            </a:solidFill>
-            <a:prstDash val="dash"/>
-          </a:ln>
-        </p:spPr>
-      </p:sp>
-      <p:sp>
-        <p:nvSpPr>
-          <p:cNvPr id="14" name="Shape 12"/>
-          <p:cNvSpPr/>
-          <p:nvPr/>
-        </p:nvSpPr>
-        <p:spPr>
-          <a:xfrm>
-            <a:off x="8717280" y="2103120"/>
-            <a:ext cx="0" cy="2606040"/>
-          </a:xfrm>
-          <a:prstGeom prst="line">
-            <a:avLst/>
-          </a:prstGeom>
-          <a:noFill/>
-          <a:ln w="6350">
-            <a:solidFill>
-              <a:srgbClr val="6B7B68"/>
-            </a:solidFill>
-            <a:prstDash val="dash"/>
-          </a:ln>
-        </p:spPr>
-      </p:sp>
-      <p:sp>
-        <p:nvSpPr>
-          <p:cNvPr id="15" name="Shape 13"/>
-          <p:cNvSpPr/>
-          <p:nvPr/>
-        </p:nvSpPr>
-        <p:spPr>
-          <a:xfrm>
-            <a:off x="10347960" y="2103120"/>
-            <a:ext cx="0" cy="2606040"/>
-          </a:xfrm>
-          <a:prstGeom prst="line">
-            <a:avLst/>
-          </a:prstGeom>
-          <a:noFill/>
-          <a:ln w="6350">
-            <a:solidFill>
-              <a:srgbClr val="6B7B68"/>
-            </a:solidFill>
-            <a:prstDash val="dash"/>
-          </a:ln>
-        </p:spPr>
-      </p:sp>
-      <p:sp>
-        <p:nvSpPr>
-          <p:cNvPr id="16" name="Shape 14"/>
-          <p:cNvSpPr/>
-          <p:nvPr/>
-        </p:nvSpPr>
-        <p:spPr>
-          <a:xfrm>
-            <a:off x="11978640" y="2103120"/>
-            <a:ext cx="0" cy="2606040"/>
-          </a:xfrm>
-          <a:prstGeom prst="line">
-            <a:avLst/>
-          </a:prstGeom>
-          <a:noFill/>
-          <a:ln w="6350">
-            <a:solidFill>
-              <a:srgbClr val="6B7B68"/>
-            </a:solidFill>
-            <a:prstDash val="dash"/>
-          </a:ln>
-        </p:spPr>
-      </p:sp>
-      <p:sp>
-        <p:nvSpPr>
-          <p:cNvPr id="17" name="Text 15"/>
-          <p:cNvSpPr/>
-          <p:nvPr/>
-        </p:nvSpPr>
-        <p:spPr>
-          <a:xfrm>
-            <a:off x="731520" y="2240280"/>
-            <a:ext cx="1280160" cy="548640"/>
-          </a:xfrm>
-          <a:prstGeom prst="rect">
-            <a:avLst/>
-          </a:prstGeom>
-          <a:noFill/>
-          <a:ln/>
-        </p:spPr>
-        <p:txBody>
-          <a:bodyPr wrap="square" lIns="0" tIns="0" rIns="0" bIns="0" rtlCol="0" anchor="ctr"/>
-          <a:lstStyle/>
-          <a:p>
-            <a:pPr algn="l" indent="0" marL="0">
-              <a:buNone/>
-            </a:pPr>
-            <a:r>
-              <a:rPr lang="en-US" sz="1300" b="1" dirty="0">
-                <a:solidFill>
-                  <a:srgbClr val="2D4A2B"/>
-                </a:solidFill>
-                <a:latin typeface="Calibri" pitchFamily="34" charset="0"/>
-                <a:ea typeface="Calibri" pitchFamily="34" charset="-122"/>
-                <a:cs typeface="Calibri" pitchFamily="34" charset="-120"/>
-              </a:rPr>
-              <a:t>Backend</a:t>
-            </a:r>
-            <a:endParaRPr lang="en-US" sz="1300" dirty="0"/>
-          </a:p>
-        </p:txBody>
-      </p:sp>
-      <p:sp>
-        <p:nvSpPr>
-          <p:cNvPr id="18" name="Shape 16"/>
-          <p:cNvSpPr/>
-          <p:nvPr/>
-        </p:nvSpPr>
-        <p:spPr>
-          <a:xfrm>
-            <a:off x="2194560" y="2103120"/>
-            <a:ext cx="9784080" cy="731520"/>
+            <a:off x="731520" y="4206240"/>
+            <a:ext cx="3291840" cy="914400"/>
           </a:xfrm>
           <a:prstGeom prst="rect">
             <a:avLst/>
@@ -2612,7 +2551,7 @@
           </a:solidFill>
           <a:ln w="12700">
             <a:solidFill>
-              <a:srgbClr val="EBE3D0"/>
+              <a:srgbClr val="5A7A4F"/>
             </a:solidFill>
             <a:prstDash val="solid"/>
           </a:ln>
@@ -2620,24 +2559,24 @@
       </p:sp>
       <p:sp>
         <p:nvSpPr>
-          <p:cNvPr id="19" name="Shape 17"/>
-          <p:cNvSpPr/>
-          <p:nvPr/>
-        </p:nvSpPr>
-        <p:spPr>
-          <a:xfrm>
-            <a:off x="2240280" y="2194560"/>
-            <a:ext cx="2354580" cy="548640"/>
-          </a:xfrm>
-          <a:prstGeom prst="rect">
+          <p:cNvPr id="13" name="Shape 11"/>
+          <p:cNvSpPr/>
+          <p:nvPr/>
+        </p:nvSpPr>
+        <p:spPr>
+          <a:xfrm>
+            <a:off x="914400" y="4389120"/>
+            <a:ext cx="548640" cy="548640"/>
+          </a:xfrm>
+          <a:prstGeom prst="ellipse">
             <a:avLst/>
           </a:prstGeom>
           <a:solidFill>
             <a:srgbClr val="2D4A2B"/>
           </a:solidFill>
-          <a:ln w="6350">
+          <a:ln w="12700">
             <a:solidFill>
-              <a:srgbClr val="1A2B19"/>
+              <a:srgbClr val="2D4A2B"/>
             </a:solidFill>
             <a:prstDash val="solid"/>
           </a:ln>
@@ -2645,14 +2584,14 @@
       </p:sp>
       <p:sp>
         <p:nvSpPr>
-          <p:cNvPr id="20" name="Text 18"/>
-          <p:cNvSpPr/>
-          <p:nvPr/>
-        </p:nvSpPr>
-        <p:spPr>
-          <a:xfrm>
-            <a:off x="2286000" y="2194560"/>
-            <a:ext cx="2263140" cy="548640"/>
+          <p:cNvPr id="14" name="Text 12"/>
+          <p:cNvSpPr/>
+          <p:nvPr/>
+        </p:nvSpPr>
+        <p:spPr>
+          <a:xfrm>
+            <a:off x="914400" y="4389120"/>
+            <a:ext cx="548640" cy="548640"/>
           </a:xfrm>
           <a:prstGeom prst="rect">
             <a:avLst/>
@@ -2668,42 +2607,42 @@
               <a:buNone/>
             </a:pPr>
             <a:r>
-              <a:rPr lang="en-US" sz="1100" b="1" dirty="0">
+              <a:rPr lang="en-US" sz="1800" b="1" dirty="0">
                 <a:solidFill>
                   <a:srgbClr val="F5EFE0"/>
                 </a:solidFill>
-                <a:latin typeface="Calibri" pitchFamily="34" charset="0"/>
-                <a:ea typeface="Calibri" pitchFamily="34" charset="-122"/>
-                <a:cs typeface="Calibri" pitchFamily="34" charset="-120"/>
-              </a:rPr>
-              <a:t>Phase 1</a:t>
-            </a:r>
-            <a:endParaRPr lang="en-US" sz="1100" dirty="0"/>
-          </a:p>
-        </p:txBody>
-      </p:sp>
-      <p:sp>
-        <p:nvSpPr>
-          <p:cNvPr id="21" name="Text 19"/>
-          <p:cNvSpPr/>
-          <p:nvPr/>
-        </p:nvSpPr>
-        <p:spPr>
-          <a:xfrm>
-            <a:off x="731520" y="3108960"/>
-            <a:ext cx="1280160" cy="548640"/>
-          </a:xfrm>
-          <a:prstGeom prst="rect">
-            <a:avLst/>
-          </a:prstGeom>
-          <a:noFill/>
-          <a:ln/>
-        </p:spPr>
-        <p:txBody>
-          <a:bodyPr wrap="square" lIns="0" tIns="0" rIns="0" bIns="0" rtlCol="0" anchor="ctr"/>
-          <a:lstStyle/>
-          <a:p>
-            <a:pPr algn="l" indent="0" marL="0">
+                <a:latin typeface="Georgia" pitchFamily="34" charset="0"/>
+                <a:ea typeface="Georgia" pitchFamily="34" charset="-122"/>
+                <a:cs typeface="Georgia" pitchFamily="34" charset="-120"/>
+              </a:rPr>
+              <a:t>2</a:t>
+            </a:r>
+            <a:endParaRPr lang="en-US" sz="1800" dirty="0"/>
+          </a:p>
+        </p:txBody>
+      </p:sp>
+      <p:sp>
+        <p:nvSpPr>
+          <p:cNvPr id="15" name="Text 13"/>
+          <p:cNvSpPr/>
+          <p:nvPr/>
+        </p:nvSpPr>
+        <p:spPr>
+          <a:xfrm>
+            <a:off x="1600200" y="4389120"/>
+            <a:ext cx="2286000" cy="274320"/>
+          </a:xfrm>
+          <a:prstGeom prst="rect">
+            <a:avLst/>
+          </a:prstGeom>
+          <a:noFill/>
+          <a:ln/>
+        </p:spPr>
+        <p:txBody>
+          <a:bodyPr wrap="square" lIns="0" tIns="0" rIns="0" bIns="0" rtlCol="0" anchor="ctr"/>
+          <a:lstStyle/>
+          <a:p>
+            <a:pPr indent="0" marL="0">
               <a:buNone/>
             </a:pPr>
             <a:r>
@@ -2715,7 +2654,7 @@
                 <a:ea typeface="Calibri" pitchFamily="34" charset="-122"/>
                 <a:cs typeface="Calibri" pitchFamily="34" charset="-120"/>
               </a:rPr>
-              <a:t>Web</a:t>
+              <a:t>Backend + Explore basic</a:t>
             </a:r>
             <a:endParaRPr lang="en-US" sz="1300" dirty="0"/>
           </a:p>
@@ -2723,14 +2662,115 @@
       </p:sp>
       <p:sp>
         <p:nvSpPr>
-          <p:cNvPr id="22" name="Shape 20"/>
-          <p:cNvSpPr/>
-          <p:nvPr/>
-        </p:nvSpPr>
-        <p:spPr>
-          <a:xfrm>
-            <a:off x="2194560" y="2971800"/>
-            <a:ext cx="9784080" cy="731520"/>
+          <p:cNvPr id="16" name="Text 14"/>
+          <p:cNvSpPr/>
+          <p:nvPr/>
+        </p:nvSpPr>
+        <p:spPr>
+          <a:xfrm>
+            <a:off x="1600200" y="4709160"/>
+            <a:ext cx="2286000" cy="274320"/>
+          </a:xfrm>
+          <a:prstGeom prst="rect">
+            <a:avLst/>
+          </a:prstGeom>
+          <a:noFill/>
+          <a:ln/>
+        </p:spPr>
+        <p:txBody>
+          <a:bodyPr wrap="square" lIns="0" tIns="0" rIns="0" bIns="0" rtlCol="0" anchor="ctr"/>
+          <a:lstStyle/>
+          <a:p>
+            <a:pPr indent="0" marL="0">
+              <a:buNone/>
+            </a:pPr>
+            <a:r>
+              <a:rPr lang="en-US" sz="1000" i="1" dirty="0">
+                <a:solidFill>
+                  <a:srgbClr val="6B7B68"/>
+                </a:solidFill>
+                <a:latin typeface="Calibri" pitchFamily="34" charset="0"/>
+                <a:ea typeface="Calibri" pitchFamily="34" charset="-122"/>
+                <a:cs typeface="Calibri" pitchFamily="34" charset="-120"/>
+              </a:rPr>
+              <a:t>Foundations</a:t>
+            </a:r>
+            <a:endParaRPr lang="en-US" sz="1000" dirty="0"/>
+          </a:p>
+        </p:txBody>
+      </p:sp>
+      <p:sp>
+        <p:nvSpPr>
+          <p:cNvPr id="17" name="Shape 15"/>
+          <p:cNvSpPr/>
+          <p:nvPr/>
+        </p:nvSpPr>
+        <p:spPr>
+          <a:xfrm>
+            <a:off x="4069080" y="4663440"/>
+            <a:ext cx="457200" cy="0"/>
+          </a:xfrm>
+          <a:prstGeom prst="line">
+            <a:avLst/>
+          </a:prstGeom>
+          <a:noFill/>
+          <a:ln w="19050">
+            <a:solidFill>
+              <a:srgbClr val="2D4A2B"/>
+            </a:solidFill>
+            <a:prstDash val="solid"/>
+          </a:ln>
+        </p:spPr>
+      </p:sp>
+      <p:sp>
+        <p:nvSpPr>
+          <p:cNvPr id="18" name="Text 16"/>
+          <p:cNvSpPr/>
+          <p:nvPr/>
+        </p:nvSpPr>
+        <p:spPr>
+          <a:xfrm>
+            <a:off x="4251960" y="4480560"/>
+            <a:ext cx="365760" cy="365760"/>
+          </a:xfrm>
+          <a:prstGeom prst="rect">
+            <a:avLst/>
+          </a:prstGeom>
+          <a:noFill/>
+          <a:ln/>
+        </p:spPr>
+        <p:txBody>
+          <a:bodyPr wrap="square" lIns="0" tIns="0" rIns="0" bIns="0" rtlCol="0" anchor="ctr"/>
+          <a:lstStyle/>
+          <a:p>
+            <a:pPr algn="ctr" indent="0" marL="0">
+              <a:buNone/>
+            </a:pPr>
+            <a:r>
+              <a:rPr lang="en-US" sz="2000" b="1" dirty="0">
+                <a:solidFill>
+                  <a:srgbClr val="2D4A2B"/>
+                </a:solidFill>
+                <a:latin typeface="Calibri" pitchFamily="34" charset="0"/>
+                <a:ea typeface="Calibri" pitchFamily="34" charset="-122"/>
+                <a:cs typeface="Calibri" pitchFamily="34" charset="-120"/>
+              </a:rPr>
+              <a:t>→</a:t>
+            </a:r>
+            <a:endParaRPr lang="en-US" sz="2000" dirty="0"/>
+          </a:p>
+        </p:txBody>
+      </p:sp>
+      <p:sp>
+        <p:nvSpPr>
+          <p:cNvPr id="19" name="Shape 17"/>
+          <p:cNvSpPr/>
+          <p:nvPr/>
+        </p:nvSpPr>
+        <p:spPr>
+          <a:xfrm>
+            <a:off x="4572000" y="4206240"/>
+            <a:ext cx="3291840" cy="914400"/>
           </a:xfrm>
           <a:prstGeom prst="rect">
             <a:avLst/>
@@ -2740,7 +2780,7 @@
           </a:solidFill>
           <a:ln w="12700">
             <a:solidFill>
-              <a:srgbClr val="EBE3D0"/>
+              <a:srgbClr val="5A7A4F"/>
             </a:solidFill>
             <a:prstDash val="solid"/>
           </a:ln>
@@ -2748,24 +2788,24 @@
       </p:sp>
       <p:sp>
         <p:nvSpPr>
-          <p:cNvPr id="23" name="Shape 21"/>
-          <p:cNvSpPr/>
-          <p:nvPr/>
-        </p:nvSpPr>
-        <p:spPr>
-          <a:xfrm>
-            <a:off x="3870960" y="3063240"/>
-            <a:ext cx="3169920" cy="548640"/>
-          </a:xfrm>
-          <a:prstGeom prst="rect">
+          <p:cNvPr id="20" name="Shape 18"/>
+          <p:cNvSpPr/>
+          <p:nvPr/>
+        </p:nvSpPr>
+        <p:spPr>
+          <a:xfrm>
+            <a:off x="4754880" y="4389120"/>
+            <a:ext cx="548640" cy="548640"/>
+          </a:xfrm>
+          <a:prstGeom prst="ellipse">
             <a:avLst/>
           </a:prstGeom>
           <a:solidFill>
             <a:srgbClr val="2D4A2B"/>
           </a:solidFill>
-          <a:ln w="6350">
+          <a:ln w="12700">
             <a:solidFill>
-              <a:srgbClr val="1A2B19"/>
+              <a:srgbClr val="2D4A2B"/>
             </a:solidFill>
             <a:prstDash val="solid"/>
           </a:ln>
@@ -2773,14 +2813,14 @@
       </p:sp>
       <p:sp>
         <p:nvSpPr>
-          <p:cNvPr id="24" name="Text 22"/>
-          <p:cNvSpPr/>
-          <p:nvPr/>
-        </p:nvSpPr>
-        <p:spPr>
-          <a:xfrm>
-            <a:off x="3916680" y="3063240"/>
-            <a:ext cx="3078480" cy="548640"/>
+          <p:cNvPr id="21" name="Text 19"/>
+          <p:cNvSpPr/>
+          <p:nvPr/>
+        </p:nvSpPr>
+        <p:spPr>
+          <a:xfrm>
+            <a:off x="4754880" y="4389120"/>
+            <a:ext cx="548640" cy="548640"/>
           </a:xfrm>
           <a:prstGeom prst="rect">
             <a:avLst/>
@@ -2796,40 +2836,116 @@
               <a:buNone/>
             </a:pPr>
             <a:r>
-              <a:rPr lang="en-US" sz="1100" b="1" dirty="0">
+              <a:rPr lang="en-US" sz="1800" b="1" dirty="0">
                 <a:solidFill>
                   <a:srgbClr val="F5EFE0"/>
                 </a:solidFill>
-                <a:latin typeface="Calibri" pitchFamily="34" charset="0"/>
-                <a:ea typeface="Calibri" pitchFamily="34" charset="-122"/>
-                <a:cs typeface="Calibri" pitchFamily="34" charset="-120"/>
-              </a:rPr>
-              <a:t>Phase 2 (Explore)</a:t>
-            </a:r>
-            <a:endParaRPr lang="en-US" sz="1100" dirty="0"/>
-          </a:p>
-        </p:txBody>
-      </p:sp>
-      <p:sp>
-        <p:nvSpPr>
-          <p:cNvPr id="25" name="Shape 23"/>
-          <p:cNvSpPr/>
-          <p:nvPr/>
-        </p:nvSpPr>
-        <p:spPr>
-          <a:xfrm>
-            <a:off x="6316980" y="3063240"/>
-            <a:ext cx="3985260" cy="548640"/>
-          </a:xfrm>
-          <a:prstGeom prst="rect">
-            <a:avLst/>
-          </a:prstGeom>
-          <a:solidFill>
-            <a:srgbClr val="2D4A2B"/>
-          </a:solidFill>
-          <a:ln w="6350">
+                <a:latin typeface="Georgia" pitchFamily="34" charset="0"/>
+                <a:ea typeface="Georgia" pitchFamily="34" charset="-122"/>
+                <a:cs typeface="Georgia" pitchFamily="34" charset="-120"/>
+              </a:rPr>
+              <a:t>3</a:t>
+            </a:r>
+            <a:endParaRPr lang="en-US" sz="1800" dirty="0"/>
+          </a:p>
+        </p:txBody>
+      </p:sp>
+      <p:sp>
+        <p:nvSpPr>
+          <p:cNvPr id="22" name="Text 20"/>
+          <p:cNvSpPr/>
+          <p:nvPr/>
+        </p:nvSpPr>
+        <p:spPr>
+          <a:xfrm>
+            <a:off x="5440680" y="4389120"/>
+            <a:ext cx="2286000" cy="274320"/>
+          </a:xfrm>
+          <a:prstGeom prst="rect">
+            <a:avLst/>
+          </a:prstGeom>
+          <a:noFill/>
+          <a:ln/>
+        </p:spPr>
+        <p:txBody>
+          <a:bodyPr wrap="square" lIns="0" tIns="0" rIns="0" bIns="0" rtlCol="0" anchor="ctr"/>
+          <a:lstStyle/>
+          <a:p>
+            <a:pPr indent="0" marL="0">
+              <a:buNone/>
+            </a:pPr>
+            <a:r>
+              <a:rPr lang="en-US" sz="1300" b="1" dirty="0">
+                <a:solidFill>
+                  <a:srgbClr val="2D4A2B"/>
+                </a:solidFill>
+                <a:latin typeface="Calibri" pitchFamily="34" charset="0"/>
+                <a:ea typeface="Calibri" pitchFamily="34" charset="-122"/>
+                <a:cs typeface="Calibri" pitchFamily="34" charset="-120"/>
+              </a:rPr>
+              <a:t>Web complete</a:t>
+            </a:r>
+            <a:endParaRPr lang="en-US" sz="1300" dirty="0"/>
+          </a:p>
+        </p:txBody>
+      </p:sp>
+      <p:sp>
+        <p:nvSpPr>
+          <p:cNvPr id="23" name="Text 21"/>
+          <p:cNvSpPr/>
+          <p:nvPr/>
+        </p:nvSpPr>
+        <p:spPr>
+          <a:xfrm>
+            <a:off x="5440680" y="4709160"/>
+            <a:ext cx="2286000" cy="274320"/>
+          </a:xfrm>
+          <a:prstGeom prst="rect">
+            <a:avLst/>
+          </a:prstGeom>
+          <a:noFill/>
+          <a:ln/>
+        </p:spPr>
+        <p:txBody>
+          <a:bodyPr wrap="square" lIns="0" tIns="0" rIns="0" bIns="0" rtlCol="0" anchor="ctr"/>
+          <a:lstStyle/>
+          <a:p>
+            <a:pPr indent="0" marL="0">
+              <a:buNone/>
+            </a:pPr>
+            <a:r>
+              <a:rPr lang="en-US" sz="1000" i="1" dirty="0">
+                <a:solidFill>
+                  <a:srgbClr val="6B7B68"/>
+                </a:solidFill>
+                <a:latin typeface="Calibri" pitchFamily="34" charset="0"/>
+                <a:ea typeface="Calibri" pitchFamily="34" charset="-122"/>
+                <a:cs typeface="Calibri" pitchFamily="34" charset="-120"/>
+              </a:rPr>
+              <a:t>Needs 2C (plot schema)</a:t>
+            </a:r>
+            <a:endParaRPr lang="en-US" sz="1000" dirty="0"/>
+          </a:p>
+        </p:txBody>
+      </p:sp>
+      <p:sp>
+        <p:nvSpPr>
+          <p:cNvPr id="24" name="Shape 22"/>
+          <p:cNvSpPr/>
+          <p:nvPr/>
+        </p:nvSpPr>
+        <p:spPr>
+          <a:xfrm>
+            <a:off x="7909560" y="4663440"/>
+            <a:ext cx="457200" cy="0"/>
+          </a:xfrm>
+          <a:prstGeom prst="line">
+            <a:avLst/>
+          </a:prstGeom>
+          <a:noFill/>
+          <a:ln w="19050">
             <a:solidFill>
-              <a:srgbClr val="1A2B19"/>
+              <a:srgbClr val="2D4A2B"/>
             </a:solidFill>
             <a:prstDash val="solid"/>
           </a:ln>
@@ -2837,14 +2953,14 @@
       </p:sp>
       <p:sp>
         <p:nvSpPr>
-          <p:cNvPr id="26" name="Text 24"/>
-          <p:cNvSpPr/>
-          <p:nvPr/>
-        </p:nvSpPr>
-        <p:spPr>
-          <a:xfrm>
-            <a:off x="6362700" y="3063240"/>
-            <a:ext cx="3893820" cy="548640"/>
+          <p:cNvPr id="25" name="Text 23"/>
+          <p:cNvSpPr/>
+          <p:nvPr/>
+        </p:nvSpPr>
+        <p:spPr>
+          <a:xfrm>
+            <a:off x="8092440" y="4480560"/>
+            <a:ext cx="365760" cy="365760"/>
           </a:xfrm>
           <a:prstGeom prst="rect">
             <a:avLst/>
@@ -2860,46 +2976,7 @@
               <a:buNone/>
             </a:pPr>
             <a:r>
-              <a:rPr lang="en-US" sz="1100" b="1" dirty="0">
-                <a:solidFill>
-                  <a:srgbClr val="F5EFE0"/>
-                </a:solidFill>
-                <a:latin typeface="Calibri" pitchFamily="34" charset="0"/>
-                <a:ea typeface="Calibri" pitchFamily="34" charset="-122"/>
-                <a:cs typeface="Calibri" pitchFamily="34" charset="-120"/>
-              </a:rPr>
-              <a:t>Phase 3 (Garden plots)</a:t>
-            </a:r>
-            <a:endParaRPr lang="en-US" sz="1100" dirty="0"/>
-          </a:p>
-        </p:txBody>
-      </p:sp>
-      <p:sp>
-        <p:nvSpPr>
-          <p:cNvPr id="27" name="Text 25"/>
-          <p:cNvSpPr/>
-          <p:nvPr/>
-        </p:nvSpPr>
-        <p:spPr>
-          <a:xfrm>
-            <a:off x="731520" y="3977640"/>
-            <a:ext cx="1280160" cy="548640"/>
-          </a:xfrm>
-          <a:prstGeom prst="rect">
-            <a:avLst/>
-          </a:prstGeom>
-          <a:noFill/>
-          <a:ln/>
-        </p:spPr>
-        <p:txBody>
-          <a:bodyPr wrap="square" lIns="0" tIns="0" rIns="0" bIns="0" rtlCol="0" anchor="ctr"/>
-          <a:lstStyle/>
-          <a:p>
-            <a:pPr algn="l" indent="0" marL="0">
-              <a:buNone/>
-            </a:pPr>
-            <a:r>
-              <a:rPr lang="en-US" sz="1300" b="1" dirty="0">
+              <a:rPr lang="en-US" sz="2000" b="1" dirty="0">
                 <a:solidFill>
                   <a:srgbClr val="2D4A2B"/>
                 </a:solidFill>
@@ -2907,22 +2984,22 @@
                 <a:ea typeface="Calibri" pitchFamily="34" charset="-122"/>
                 <a:cs typeface="Calibri" pitchFamily="34" charset="-120"/>
               </a:rPr>
-              <a:t>Android</a:t>
-            </a:r>
-            <a:endParaRPr lang="en-US" sz="1300" dirty="0"/>
-          </a:p>
-        </p:txBody>
-      </p:sp>
-      <p:sp>
-        <p:nvSpPr>
-          <p:cNvPr id="28" name="Shape 26"/>
-          <p:cNvSpPr/>
-          <p:nvPr/>
-        </p:nvSpPr>
-        <p:spPr>
-          <a:xfrm>
-            <a:off x="2194560" y="3840480"/>
-            <a:ext cx="9784080" cy="731520"/>
+              <a:t>→</a:t>
+            </a:r>
+            <a:endParaRPr lang="en-US" sz="2000" dirty="0"/>
+          </a:p>
+        </p:txBody>
+      </p:sp>
+      <p:sp>
+        <p:nvSpPr>
+          <p:cNvPr id="26" name="Shape 24"/>
+          <p:cNvSpPr/>
+          <p:nvPr/>
+        </p:nvSpPr>
+        <p:spPr>
+          <a:xfrm>
+            <a:off x="8412480" y="4206240"/>
+            <a:ext cx="3291840" cy="914400"/>
           </a:xfrm>
           <a:prstGeom prst="rect">
             <a:avLst/>
@@ -2932,7 +3009,7 @@
           </a:solidFill>
           <a:ln w="12700">
             <a:solidFill>
-              <a:srgbClr val="EBE3D0"/>
+              <a:srgbClr val="5A7A4F"/>
             </a:solidFill>
             <a:prstDash val="solid"/>
           </a:ln>
@@ -2940,24 +3017,24 @@
       </p:sp>
       <p:sp>
         <p:nvSpPr>
-          <p:cNvPr id="29" name="Shape 27"/>
-          <p:cNvSpPr/>
-          <p:nvPr/>
-        </p:nvSpPr>
-        <p:spPr>
-          <a:xfrm>
-            <a:off x="8763000" y="3931920"/>
-            <a:ext cx="3169920" cy="548640"/>
-          </a:xfrm>
-          <a:prstGeom prst="rect">
+          <p:cNvPr id="27" name="Shape 25"/>
+          <p:cNvSpPr/>
+          <p:nvPr/>
+        </p:nvSpPr>
+        <p:spPr>
+          <a:xfrm>
+            <a:off x="8595360" y="4389120"/>
+            <a:ext cx="548640" cy="548640"/>
+          </a:xfrm>
+          <a:prstGeom prst="ellipse">
             <a:avLst/>
           </a:prstGeom>
           <a:solidFill>
             <a:srgbClr val="2D4A2B"/>
           </a:solidFill>
-          <a:ln w="6350">
+          <a:ln w="12700">
             <a:solidFill>
-              <a:srgbClr val="1A2B19"/>
+              <a:srgbClr val="2D4A2B"/>
             </a:solidFill>
             <a:prstDash val="solid"/>
           </a:ln>
@@ -2965,40 +3042,118 @@
       </p:sp>
       <p:sp>
         <p:nvSpPr>
+          <p:cNvPr id="28" name="Text 26"/>
+          <p:cNvSpPr/>
+          <p:nvPr/>
+        </p:nvSpPr>
+        <p:spPr>
+          <a:xfrm>
+            <a:off x="8595360" y="4389120"/>
+            <a:ext cx="548640" cy="548640"/>
+          </a:xfrm>
+          <a:prstGeom prst="rect">
+            <a:avLst/>
+          </a:prstGeom>
+          <a:noFill/>
+          <a:ln/>
+        </p:spPr>
+        <p:txBody>
+          <a:bodyPr wrap="square" lIns="0" tIns="0" rIns="0" bIns="0" rtlCol="0" anchor="ctr"/>
+          <a:lstStyle/>
+          <a:p>
+            <a:pPr algn="ctr" indent="0" marL="0">
+              <a:buNone/>
+            </a:pPr>
+            <a:r>
+              <a:rPr lang="en-US" sz="1800" b="1" dirty="0">
+                <a:solidFill>
+                  <a:srgbClr val="F5EFE0"/>
+                </a:solidFill>
+                <a:latin typeface="Georgia" pitchFamily="34" charset="0"/>
+                <a:ea typeface="Georgia" pitchFamily="34" charset="-122"/>
+                <a:cs typeface="Georgia" pitchFamily="34" charset="-120"/>
+              </a:rPr>
+              <a:t>4</a:t>
+            </a:r>
+            <a:endParaRPr lang="en-US" sz="1800" dirty="0"/>
+          </a:p>
+        </p:txBody>
+      </p:sp>
+      <p:sp>
+        <p:nvSpPr>
+          <p:cNvPr id="29" name="Text 27"/>
+          <p:cNvSpPr/>
+          <p:nvPr/>
+        </p:nvSpPr>
+        <p:spPr>
+          <a:xfrm>
+            <a:off x="9281160" y="4389120"/>
+            <a:ext cx="2286000" cy="274320"/>
+          </a:xfrm>
+          <a:prstGeom prst="rect">
+            <a:avLst/>
+          </a:prstGeom>
+          <a:noFill/>
+          <a:ln/>
+        </p:spPr>
+        <p:txBody>
+          <a:bodyPr wrap="square" lIns="0" tIns="0" rIns="0" bIns="0" rtlCol="0" anchor="ctr"/>
+          <a:lstStyle/>
+          <a:p>
+            <a:pPr indent="0" marL="0">
+              <a:buNone/>
+            </a:pPr>
+            <a:r>
+              <a:rPr lang="en-US" sz="1300" b="1" dirty="0">
+                <a:solidFill>
+                  <a:srgbClr val="2D4A2B"/>
+                </a:solidFill>
+                <a:latin typeface="Calibri" pitchFamily="34" charset="0"/>
+                <a:ea typeface="Calibri" pitchFamily="34" charset="-122"/>
+                <a:cs typeface="Calibri" pitchFamily="34" charset="-120"/>
+              </a:rPr>
+              <a:t>Android adoption</a:t>
+            </a:r>
+            <a:endParaRPr lang="en-US" sz="1300" dirty="0"/>
+          </a:p>
+        </p:txBody>
+      </p:sp>
+      <p:sp>
+        <p:nvSpPr>
           <p:cNvPr id="30" name="Text 28"/>
           <p:cNvSpPr/>
           <p:nvPr/>
         </p:nvSpPr>
         <p:spPr>
           <a:xfrm>
-            <a:off x="8808720" y="3931920"/>
-            <a:ext cx="3078480" cy="548640"/>
-          </a:xfrm>
-          <a:prstGeom prst="rect">
-            <a:avLst/>
-          </a:prstGeom>
-          <a:noFill/>
-          <a:ln/>
-        </p:spPr>
-        <p:txBody>
-          <a:bodyPr wrap="square" lIns="0" tIns="0" rIns="0" bIns="0" rtlCol="0" anchor="ctr"/>
-          <a:lstStyle/>
-          <a:p>
-            <a:pPr algn="ctr" indent="0" marL="0">
-              <a:buNone/>
-            </a:pPr>
-            <a:r>
-              <a:rPr lang="en-US" sz="1100" b="1" dirty="0">
-                <a:solidFill>
-                  <a:srgbClr val="F5EFE0"/>
-                </a:solidFill>
-                <a:latin typeface="Calibri" pitchFamily="34" charset="0"/>
-                <a:ea typeface="Calibri" pitchFamily="34" charset="-122"/>
-                <a:cs typeface="Calibri" pitchFamily="34" charset="-120"/>
-              </a:rPr>
-              <a:t>Phase 4</a:t>
-            </a:r>
-            <a:endParaRPr lang="en-US" sz="1100" dirty="0"/>
+            <a:off x="9281160" y="4709160"/>
+            <a:ext cx="2286000" cy="274320"/>
+          </a:xfrm>
+          <a:prstGeom prst="rect">
+            <a:avLst/>
+          </a:prstGeom>
+          <a:noFill/>
+          <a:ln/>
+        </p:spPr>
+        <p:txBody>
+          <a:bodyPr wrap="square" lIns="0" tIns="0" rIns="0" bIns="0" rtlCol="0" anchor="ctr"/>
+          <a:lstStyle/>
+          <a:p>
+            <a:pPr indent="0" marL="0">
+              <a:buNone/>
+            </a:pPr>
+            <a:r>
+              <a:rPr lang="en-US" sz="1000" i="1" dirty="0">
+                <a:solidFill>
+                  <a:srgbClr val="6B7B68"/>
+                </a:solidFill>
+                <a:latin typeface="Calibri" pitchFamily="34" charset="0"/>
+                <a:ea typeface="Calibri" pitchFamily="34" charset="-122"/>
+                <a:cs typeface="Calibri" pitchFamily="34" charset="-120"/>
+              </a:rPr>
+              <a:t>Needs web design language settled</a:t>
+            </a:r>
+            <a:endParaRPr lang="en-US" sz="1000" dirty="0"/>
           </a:p>
         </p:txBody>
       </p:sp>
@@ -3010,7 +3165,7 @@
         </p:nvSpPr>
         <p:spPr>
           <a:xfrm>
-            <a:off x="731520" y="5029200"/>
+            <a:off x="731520" y="5486400"/>
             <a:ext cx="10972800" cy="274320"/>
           </a:xfrm>
           <a:prstGeom prst="rect">
@@ -3035,7 +3190,7 @@
                 <a:ea typeface="Calibri" pitchFamily="34" charset="-122"/>
                 <a:cs typeface="Calibri" pitchFamily="34" charset="-120"/>
               </a:rPr>
-              <a:t>Critical path</a:t>
+              <a:t>Notes</a:t>
             </a:r>
             <a:endParaRPr lang="en-US" sz="1300" dirty="0"/>
           </a:p>
@@ -3049,8 +3204,8 @@
         </p:nvSpPr>
         <p:spPr>
           <a:xfrm>
-            <a:off x="731520" y="5349240"/>
-            <a:ext cx="10972800" cy="1097280"/>
+            <a:off x="731520" y="5760720"/>
+            <a:ext cx="10972800" cy="914400"/>
           </a:xfrm>
           <a:prstGeom prst="rect">
             <a:avLst/>
@@ -3066,7 +3221,7 @@
               <a:buNone/>
             </a:pPr>
             <a:r>
-              <a:rPr lang="en-US" sz="1300" dirty="0">
+              <a:rPr lang="en-US" sz="1200" dirty="0">
                 <a:solidFill>
                   <a:srgbClr val="1A2B19"/>
                 </a:solidFill>
@@ -3074,22 +3229,22 @@
                 <a:ea typeface="Calibri" pitchFamily="34" charset="-122"/>
                 <a:cs typeface="Calibri" pitchFamily="34" charset="-120"/>
               </a:rPr>
-              <a:t>Phase 1 (backend) → Phase 2 (web Explore) → Phase 3 (web Garden) → Phase 4 (Android). Backend partially unblocks both Phases 2 and 3, but 1C (plot schema) must land before 3 starts.</a:t>
-            </a:r>
-            <a:endParaRPr lang="en-US" sz="1300" dirty="0"/>
+              <a:t>Web Explore (in Deliverable 2) ships before Garden plots (Deliverable 3) starts in earnest — Explore acts as the user fallback during the Garden transition. </a:t>
+            </a:r>
+            <a:endParaRPr lang="en-US" sz="1200" dirty="0"/>
           </a:p>
           <a:p>
             <a:pPr indent="0" marL="0">
               <a:buNone/>
             </a:pPr>
-            <a:endParaRPr lang="en-US" sz="1300" dirty="0"/>
+            <a:endParaRPr lang="en-US" sz="1200" dirty="0"/>
           </a:p>
           <a:p>
             <a:pPr indent="0" marL="0">
               <a:buNone/>
             </a:pPr>
             <a:r>
-              <a:rPr lang="en-US" sz="1300" dirty="0">
+              <a:rPr lang="en-US" sz="1200" dirty="0">
                 <a:solidFill>
                   <a:srgbClr val="1A2B19"/>
                 </a:solidFill>
@@ -3097,9 +3252,9 @@
                 <a:ea typeface="Calibri" pitchFamily="34" charset="-122"/>
                 <a:cs typeface="Calibri" pitchFamily="34" charset="-120"/>
               </a:rPr>
-              <a:t>Web Explore (Phase 2) should ship before Garden plots (Phase 3) starts in earnest — Explore acts as user fallback during the Garden transition. Some overlap acceptable late in Phase 2.</a:t>
-            </a:r>
-            <a:endParaRPr lang="en-US" sz="1300" dirty="0"/>
+              <a:t>Android (Deliverable 4) waits for web (Deliverable 3) so the design patterns are settled before the Compose implementation begins.</a:t>
+            </a:r>
+            <a:endParaRPr lang="en-US" sz="1200" dirty="0"/>
           </a:p>
         </p:txBody>
       </p:sp>
@@ -3310,7 +3465,7 @@
                 <a:ea typeface="Calibri" pitchFamily="34" charset="-122"/>
                 <a:cs typeface="Calibri" pitchFamily="34" charset="-120"/>
               </a:rPr>
-              <a:t>Sequential — phase by phase</a:t>
+              <a:t>Sequential — deliverable by deliverable</a:t>
             </a:r>
             <a:endParaRPr lang="en-US" sz="1200" dirty="0"/>
           </a:p>
@@ -3427,7 +3582,7 @@
                 <a:ea typeface="Calibri" pitchFamily="34" charset="-122"/>
                 <a:cs typeface="Calibri" pitchFamily="34" charset="-120"/>
               </a:rPr>
-              <a:t>9 increments × ~2 days each, plus review, debugging, doc updates, deployment. The honest baseline.</a:t>
+              <a:t>Four deliverables × ~1+ week each + review and buffer. The honest traditional baseline.</a:t>
             </a:r>
             <a:endParaRPr lang="en-US" sz="1100" dirty="0"/>
           </a:p>
@@ -3647,7 +3802,7 @@
                 <a:ea typeface="Calibri" pitchFamily="34" charset="-122"/>
                 <a:cs typeface="Calibri" pitchFamily="34" charset="-120"/>
               </a:rPr>
-              <a:t>Backend stream and web stream can overlap. Engineer A on backend + Phase 4; Engineer B on web Phases 2 and 3.</a:t>
+              <a:t>Backend and web can overlap; D4 (Android) waits for the web design language to settle.</a:t>
             </a:r>
             <a:endParaRPr lang="en-US" sz="1100" dirty="0"/>
           </a:p>
@@ -3867,7 +4022,7 @@
                 <a:ea typeface="Calibri" pitchFamily="34" charset="-122"/>
                 <a:cs typeface="Calibri" pitchFamily="34" charset="-120"/>
               </a:rPr>
-              <a:t>Backend increments split across one engineer; web Phases 2 and 3 split across the other two. Diminishing returns past three.</a:t>
+              <a:t>Backend, web, and Android split across three. Diminishing returns past three given the deliverable dependencies.</a:t>
             </a:r>
             <a:endParaRPr lang="en-US" sz="1100" dirty="0"/>
           </a:p>
@@ -3923,6 +4078,1046 @@
 <file path=ppt/slides/slide12.xml><?xml version="1.0" encoding="utf-8"?>
 <p:sld xmlns:a="http://schemas.openxmlformats.org/drawingml/2006/main" xmlns:r="http://schemas.openxmlformats.org/officeDocument/2006/relationships" xmlns:p="http://schemas.openxmlformats.org/presentationml/2006/main">
   <p:cSld name="Slide 12">
+    <p:bg>
+      <p:bgPr>
+        <a:solidFill>
+          <a:srgbClr val="F5EFE0"/>
+        </a:solidFill>
+      </p:bgPr>
+    </p:bg>
+    <p:spTree>
+      <p:nvGrpSpPr>
+        <p:cNvPr id="1" name=""/>
+        <p:cNvGrpSpPr/>
+        <p:nvPr/>
+      </p:nvGrpSpPr>
+      <p:grpSpPr>
+        <a:xfrm>
+          <a:off x="0" y="0"/>
+          <a:ext cx="0" cy="0"/>
+          <a:chOff x="0" y="0"/>
+          <a:chExt cx="0" cy="0"/>
+        </a:xfrm>
+      </p:grpSpPr>
+      <p:sp>
+        <p:nvSpPr>
+          <p:cNvPr id="2" name="Text 0"/>
+          <p:cNvSpPr/>
+          <p:nvPr/>
+        </p:nvSpPr>
+        <p:spPr>
+          <a:xfrm>
+            <a:off x="731520" y="457200"/>
+            <a:ext cx="10972800" cy="731520"/>
+          </a:xfrm>
+          <a:prstGeom prst="rect">
+            <a:avLst/>
+          </a:prstGeom>
+          <a:noFill/>
+          <a:ln/>
+        </p:spPr>
+        <p:txBody>
+          <a:bodyPr wrap="square" lIns="0" tIns="0" rIns="0" bIns="0" rtlCol="0" anchor="ctr"/>
+          <a:lstStyle/>
+          <a:p>
+            <a:pPr algn="l" indent="0" marL="0">
+              <a:buNone/>
+            </a:pPr>
+            <a:r>
+              <a:rPr lang="en-US" sz="3600" i="1" dirty="0">
+                <a:solidFill>
+                  <a:srgbClr val="2D4A2B"/>
+                </a:solidFill>
+                <a:latin typeface="Georgia" pitchFamily="34" charset="0"/>
+                <a:ea typeface="Georgia" pitchFamily="34" charset="-122"/>
+                <a:cs typeface="Georgia" pitchFamily="34" charset="-120"/>
+              </a:rPr>
+              <a:t>Velocity</a:t>
+            </a:r>
+            <a:endParaRPr lang="en-US" sz="3600" dirty="0"/>
+          </a:p>
+        </p:txBody>
+      </p:sp>
+      <p:sp>
+        <p:nvSpPr>
+          <p:cNvPr id="3" name="Text 1"/>
+          <p:cNvSpPr/>
+          <p:nvPr/>
+        </p:nvSpPr>
+        <p:spPr>
+          <a:xfrm>
+            <a:off x="731520" y="1280160"/>
+            <a:ext cx="10972800" cy="457200"/>
+          </a:xfrm>
+          <a:prstGeom prst="rect">
+            <a:avLst/>
+          </a:prstGeom>
+          <a:noFill/>
+          <a:ln/>
+        </p:spPr>
+        <p:txBody>
+          <a:bodyPr wrap="square" lIns="0" tIns="0" rIns="0" bIns="0" rtlCol="0" anchor="ctr"/>
+          <a:lstStyle/>
+          <a:p>
+            <a:pPr algn="l" indent="0" marL="0">
+              <a:buNone/>
+            </a:pPr>
+            <a:r>
+              <a:rPr lang="en-US" sz="1600" i="1" dirty="0">
+                <a:solidFill>
+                  <a:srgbClr val="6B7B68"/>
+                </a:solidFill>
+                <a:latin typeface="Calibri" pitchFamily="34" charset="0"/>
+                <a:ea typeface="Calibri" pitchFamily="34" charset="-122"/>
+                <a:cs typeface="Calibri" pitchFamily="34" charset="-120"/>
+              </a:rPr>
+              <a:t>Why traditional estimates feel high — and a more honest reframe.</a:t>
+            </a:r>
+            <a:endParaRPr lang="en-US" sz="1600" dirty="0"/>
+          </a:p>
+        </p:txBody>
+      </p:sp>
+      <p:sp>
+        <p:nvSpPr>
+          <p:cNvPr id="4" name="Shape 2"/>
+          <p:cNvSpPr/>
+          <p:nvPr/>
+        </p:nvSpPr>
+        <p:spPr>
+          <a:xfrm>
+            <a:off x="731520" y="2011680"/>
+            <a:ext cx="5212080" cy="2286000"/>
+          </a:xfrm>
+          <a:prstGeom prst="rect">
+            <a:avLst/>
+          </a:prstGeom>
+          <a:solidFill>
+            <a:srgbClr val="EBE3D0"/>
+          </a:solidFill>
+          <a:ln w="12700">
+            <a:solidFill>
+              <a:srgbClr val="5A7A4F"/>
+            </a:solidFill>
+            <a:prstDash val="solid"/>
+          </a:ln>
+        </p:spPr>
+      </p:sp>
+      <p:sp>
+        <p:nvSpPr>
+          <p:cNvPr id="5" name="Text 3"/>
+          <p:cNvSpPr/>
+          <p:nvPr/>
+        </p:nvSpPr>
+        <p:spPr>
+          <a:xfrm>
+            <a:off x="914400" y="2286000"/>
+            <a:ext cx="4846320" cy="365760"/>
+          </a:xfrm>
+          <a:prstGeom prst="rect">
+            <a:avLst/>
+          </a:prstGeom>
+          <a:noFill/>
+          <a:ln/>
+        </p:spPr>
+        <p:txBody>
+          <a:bodyPr wrap="square" lIns="0" tIns="0" rIns="0" bIns="0" rtlCol="0" anchor="ctr"/>
+          <a:lstStyle/>
+          <a:p>
+            <a:pPr indent="0" marL="0">
+              <a:buNone/>
+            </a:pPr>
+            <a:r>
+              <a:rPr lang="en-US" sz="1200" b="1" spc="600" kern="0" dirty="0">
+                <a:solidFill>
+                  <a:srgbClr val="6B7B68"/>
+                </a:solidFill>
+                <a:latin typeface="Calibri" pitchFamily="34" charset="0"/>
+                <a:ea typeface="Calibri" pitchFamily="34" charset="-122"/>
+                <a:cs typeface="Calibri" pitchFamily="34" charset="-120"/>
+              </a:rPr>
+              <a:t>SOLO, SPARE TIME</a:t>
+            </a:r>
+            <a:endParaRPr lang="en-US" sz="1200" dirty="0"/>
+          </a:p>
+        </p:txBody>
+      </p:sp>
+      <p:sp>
+        <p:nvSpPr>
+          <p:cNvPr id="6" name="Text 4"/>
+          <p:cNvSpPr/>
+          <p:nvPr/>
+        </p:nvSpPr>
+        <p:spPr>
+          <a:xfrm>
+            <a:off x="914400" y="2743200"/>
+            <a:ext cx="4846320" cy="914400"/>
+          </a:xfrm>
+          <a:prstGeom prst="rect">
+            <a:avLst/>
+          </a:prstGeom>
+          <a:noFill/>
+          <a:ln/>
+        </p:spPr>
+        <p:txBody>
+          <a:bodyPr wrap="square" lIns="0" tIns="0" rIns="0" bIns="0" rtlCol="0" anchor="ctr"/>
+          <a:lstStyle/>
+          <a:p>
+            <a:pPr algn="ctr" indent="0" marL="0">
+              <a:buNone/>
+            </a:pPr>
+            <a:r>
+              <a:rPr lang="en-US" sz="6000" dirty="0">
+                <a:solidFill>
+                  <a:srgbClr val="2D4A2B"/>
+                </a:solidFill>
+                <a:latin typeface="Georgia" pitchFamily="34" charset="0"/>
+                <a:ea typeface="Georgia" pitchFamily="34" charset="-122"/>
+                <a:cs typeface="Georgia" pitchFamily="34" charset="-120"/>
+              </a:rPr>
+              <a:t>~1 year</a:t>
+            </a:r>
+            <a:endParaRPr lang="en-US" sz="6000" dirty="0"/>
+          </a:p>
+        </p:txBody>
+      </p:sp>
+      <p:sp>
+        <p:nvSpPr>
+          <p:cNvPr id="7" name="Text 5"/>
+          <p:cNvSpPr/>
+          <p:nvPr/>
+        </p:nvSpPr>
+        <p:spPr>
+          <a:xfrm>
+            <a:off x="914400" y="3794760"/>
+            <a:ext cx="4846320" cy="457200"/>
+          </a:xfrm>
+          <a:prstGeom prst="rect">
+            <a:avLst/>
+          </a:prstGeom>
+          <a:noFill/>
+          <a:ln/>
+        </p:spPr>
+        <p:txBody>
+          <a:bodyPr wrap="square" lIns="0" tIns="0" rIns="0" bIns="0" rtlCol="0" anchor="ctr"/>
+          <a:lstStyle/>
+          <a:p>
+            <a:pPr algn="ctr" indent="0" marL="0">
+              <a:buNone/>
+            </a:pPr>
+            <a:r>
+              <a:rPr lang="en-US" sz="1200" dirty="0">
+                <a:solidFill>
+                  <a:srgbClr val="1A2B19"/>
+                </a:solidFill>
+                <a:latin typeface="Calibri" pitchFamily="34" charset="0"/>
+                <a:ea typeface="Calibri" pitchFamily="34" charset="-122"/>
+                <a:cs typeface="Calibri" pitchFamily="34" charset="-120"/>
+              </a:rPr>
+              <a:t>Evenings and weekends. The pace a single founder typically moves at on a side project.</a:t>
+            </a:r>
+            <a:endParaRPr lang="en-US" sz="1200" dirty="0"/>
+          </a:p>
+        </p:txBody>
+      </p:sp>
+      <p:sp>
+        <p:nvSpPr>
+          <p:cNvPr id="8" name="Shape 6"/>
+          <p:cNvSpPr/>
+          <p:nvPr/>
+        </p:nvSpPr>
+        <p:spPr>
+          <a:xfrm>
+            <a:off x="6309360" y="2011680"/>
+            <a:ext cx="5212080" cy="2286000"/>
+          </a:xfrm>
+          <a:prstGeom prst="rect">
+            <a:avLst/>
+          </a:prstGeom>
+          <a:solidFill>
+            <a:srgbClr val="2D4A2B"/>
+          </a:solidFill>
+          <a:ln w="12700">
+            <a:solidFill>
+              <a:srgbClr val="2D4A2B"/>
+            </a:solidFill>
+            <a:prstDash val="solid"/>
+          </a:ln>
+        </p:spPr>
+      </p:sp>
+      <p:sp>
+        <p:nvSpPr>
+          <p:cNvPr id="9" name="Text 7"/>
+          <p:cNvSpPr/>
+          <p:nvPr/>
+        </p:nvSpPr>
+        <p:spPr>
+          <a:xfrm>
+            <a:off x="6492240" y="2286000"/>
+            <a:ext cx="4846320" cy="365760"/>
+          </a:xfrm>
+          <a:prstGeom prst="rect">
+            <a:avLst/>
+          </a:prstGeom>
+          <a:noFill/>
+          <a:ln/>
+        </p:spPr>
+        <p:txBody>
+          <a:bodyPr wrap="square" lIns="0" tIns="0" rIns="0" bIns="0" rtlCol="0" anchor="ctr"/>
+          <a:lstStyle/>
+          <a:p>
+            <a:pPr indent="0" marL="0">
+              <a:buNone/>
+            </a:pPr>
+            <a:r>
+              <a:rPr lang="en-US" sz="1200" b="1" spc="600" kern="0" dirty="0">
+                <a:solidFill>
+                  <a:srgbClr val="D4A5A5"/>
+                </a:solidFill>
+                <a:latin typeface="Calibri" pitchFamily="34" charset="0"/>
+                <a:ea typeface="Calibri" pitchFamily="34" charset="-122"/>
+                <a:cs typeface="Calibri" pitchFamily="34" charset="-120"/>
+              </a:rPr>
+              <a:t>FOUNDER + AI</a:t>
+            </a:r>
+            <a:endParaRPr lang="en-US" sz="1200" dirty="0"/>
+          </a:p>
+        </p:txBody>
+      </p:sp>
+      <p:sp>
+        <p:nvSpPr>
+          <p:cNvPr id="10" name="Text 8"/>
+          <p:cNvSpPr/>
+          <p:nvPr/>
+        </p:nvSpPr>
+        <p:spPr>
+          <a:xfrm>
+            <a:off x="6492240" y="2743200"/>
+            <a:ext cx="4846320" cy="914400"/>
+          </a:xfrm>
+          <a:prstGeom prst="rect">
+            <a:avLst/>
+          </a:prstGeom>
+          <a:noFill/>
+          <a:ln/>
+        </p:spPr>
+        <p:txBody>
+          <a:bodyPr wrap="square" lIns="0" tIns="0" rIns="0" bIns="0" rtlCol="0" anchor="ctr"/>
+          <a:lstStyle/>
+          <a:p>
+            <a:pPr algn="ctr" indent="0" marL="0">
+              <a:buNone/>
+            </a:pPr>
+            <a:r>
+              <a:rPr lang="en-US" sz="6000" dirty="0">
+                <a:solidFill>
+                  <a:srgbClr val="F5EFE0"/>
+                </a:solidFill>
+                <a:latin typeface="Georgia" pitchFamily="34" charset="0"/>
+                <a:ea typeface="Georgia" pitchFamily="34" charset="-122"/>
+                <a:cs typeface="Georgia" pitchFamily="34" charset="-120"/>
+              </a:rPr>
+              <a:t>~9 days</a:t>
+            </a:r>
+            <a:endParaRPr lang="en-US" sz="6000" dirty="0"/>
+          </a:p>
+        </p:txBody>
+      </p:sp>
+      <p:sp>
+        <p:nvSpPr>
+          <p:cNvPr id="11" name="Text 9"/>
+          <p:cNvSpPr/>
+          <p:nvPr/>
+        </p:nvSpPr>
+        <p:spPr>
+          <a:xfrm>
+            <a:off x="6492240" y="3794760"/>
+            <a:ext cx="4846320" cy="457200"/>
+          </a:xfrm>
+          <a:prstGeom prst="rect">
+            <a:avLst/>
+          </a:prstGeom>
+          <a:noFill/>
+          <a:ln/>
+        </p:spPr>
+        <p:txBody>
+          <a:bodyPr wrap="square" lIns="0" tIns="0" rIns="0" bIns="0" rtlCol="0" anchor="ctr"/>
+          <a:lstStyle/>
+          <a:p>
+            <a:pPr algn="ctr" indent="0" marL="0">
+              <a:buNone/>
+            </a:pPr>
+            <a:r>
+              <a:rPr lang="en-US" sz="1200" dirty="0">
+                <a:solidFill>
+                  <a:srgbClr val="F5EFE0"/>
+                </a:solidFill>
+                <a:latin typeface="Calibri" pitchFamily="34" charset="0"/>
+                <a:ea typeface="Calibri" pitchFamily="34" charset="-122"/>
+                <a:cs typeface="Calibri" pitchFamily="34" charset="-120"/>
+              </a:rPr>
+              <a:t>End of April to 8 May. The project to date — backend, web, Android, brand work, ~49 integration tests for capsules alone.</a:t>
+            </a:r>
+            <a:endParaRPr lang="en-US" sz="1200" dirty="0"/>
+          </a:p>
+        </p:txBody>
+      </p:sp>
+      <p:sp>
+        <p:nvSpPr>
+          <p:cNvPr id="12" name="Text 10"/>
+          <p:cNvSpPr/>
+          <p:nvPr/>
+        </p:nvSpPr>
+        <p:spPr>
+          <a:xfrm>
+            <a:off x="731520" y="4526280"/>
+            <a:ext cx="10972800" cy="365760"/>
+          </a:xfrm>
+          <a:prstGeom prst="rect">
+            <a:avLst/>
+          </a:prstGeom>
+          <a:noFill/>
+          <a:ln/>
+        </p:spPr>
+        <p:txBody>
+          <a:bodyPr wrap="square" lIns="0" tIns="0" rIns="0" bIns="0" rtlCol="0" anchor="ctr"/>
+          <a:lstStyle/>
+          <a:p>
+            <a:pPr indent="0" marL="0">
+              <a:buNone/>
+            </a:pPr>
+            <a:r>
+              <a:rPr lang="en-US" sz="1300" b="1" spc="400" kern="0" dirty="0">
+                <a:solidFill>
+                  <a:srgbClr val="2D4A2B"/>
+                </a:solidFill>
+                <a:latin typeface="Calibri" pitchFamily="34" charset="0"/>
+                <a:ea typeface="Calibri" pitchFamily="34" charset="-122"/>
+                <a:cs typeface="Calibri" pitchFamily="34" charset="-120"/>
+              </a:rPr>
+              <a:t>What this means for Milestone 6</a:t>
+            </a:r>
+            <a:endParaRPr lang="en-US" sz="1300" dirty="0"/>
+          </a:p>
+        </p:txBody>
+      </p:sp>
+      <p:sp>
+        <p:nvSpPr>
+          <p:cNvPr id="13" name="Shape 11"/>
+          <p:cNvSpPr/>
+          <p:nvPr/>
+        </p:nvSpPr>
+        <p:spPr>
+          <a:xfrm>
+            <a:off x="731520" y="4937760"/>
+            <a:ext cx="2670048" cy="960120"/>
+          </a:xfrm>
+          <a:prstGeom prst="rect">
+            <a:avLst/>
+          </a:prstGeom>
+          <a:solidFill>
+            <a:srgbClr val="EBE3D0"/>
+          </a:solidFill>
+          <a:ln w="12700">
+            <a:solidFill>
+              <a:srgbClr val="5A7A4F"/>
+            </a:solidFill>
+            <a:prstDash val="solid"/>
+          </a:ln>
+        </p:spPr>
+      </p:sp>
+      <p:sp>
+        <p:nvSpPr>
+          <p:cNvPr id="14" name="Text 12"/>
+          <p:cNvSpPr/>
+          <p:nvPr/>
+        </p:nvSpPr>
+        <p:spPr>
+          <a:xfrm>
+            <a:off x="914400" y="5029200"/>
+            <a:ext cx="2304288" cy="274320"/>
+          </a:xfrm>
+          <a:prstGeom prst="rect">
+            <a:avLst/>
+          </a:prstGeom>
+          <a:noFill/>
+          <a:ln/>
+        </p:spPr>
+        <p:txBody>
+          <a:bodyPr wrap="square" lIns="0" tIns="0" rIns="0" bIns="0" rtlCol="0" anchor="ctr"/>
+          <a:lstStyle/>
+          <a:p>
+            <a:pPr indent="0" marL="0">
+              <a:buNone/>
+            </a:pPr>
+            <a:r>
+              <a:rPr lang="en-US" sz="1000" b="1" spc="400" kern="0" dirty="0">
+                <a:solidFill>
+                  <a:srgbClr val="D4A5A5"/>
+                </a:solidFill>
+                <a:latin typeface="Calibri" pitchFamily="34" charset="0"/>
+                <a:ea typeface="Calibri" pitchFamily="34" charset="-122"/>
+                <a:cs typeface="Calibri" pitchFamily="34" charset="-120"/>
+              </a:rPr>
+              <a:t>SESSION 1</a:t>
+            </a:r>
+            <a:endParaRPr lang="en-US" sz="1000" dirty="0"/>
+          </a:p>
+        </p:txBody>
+      </p:sp>
+      <p:sp>
+        <p:nvSpPr>
+          <p:cNvPr id="15" name="Text 13"/>
+          <p:cNvSpPr/>
+          <p:nvPr/>
+        </p:nvSpPr>
+        <p:spPr>
+          <a:xfrm>
+            <a:off x="914400" y="5257800"/>
+            <a:ext cx="2304288" cy="274320"/>
+          </a:xfrm>
+          <a:prstGeom prst="rect">
+            <a:avLst/>
+          </a:prstGeom>
+          <a:noFill/>
+          <a:ln/>
+        </p:spPr>
+        <p:txBody>
+          <a:bodyPr wrap="square" lIns="0" tIns="0" rIns="0" bIns="0" rtlCol="0" anchor="ctr"/>
+          <a:lstStyle/>
+          <a:p>
+            <a:pPr indent="0" marL="0">
+              <a:buNone/>
+            </a:pPr>
+            <a:r>
+              <a:rPr lang="en-US" sz="1300" b="1" dirty="0">
+                <a:solidFill>
+                  <a:srgbClr val="2D4A2B"/>
+                </a:solidFill>
+                <a:latin typeface="Calibri" pitchFamily="34" charset="0"/>
+                <a:ea typeface="Calibri" pitchFamily="34" charset="-122"/>
+                <a:cs typeface="Calibri" pitchFamily="34" charset="-120"/>
+              </a:rPr>
+              <a:t>Tools</a:t>
+            </a:r>
+            <a:endParaRPr lang="en-US" sz="1300" dirty="0"/>
+          </a:p>
+        </p:txBody>
+      </p:sp>
+      <p:sp>
+        <p:nvSpPr>
+          <p:cNvPr id="16" name="Text 14"/>
+          <p:cNvSpPr/>
+          <p:nvPr/>
+        </p:nvSpPr>
+        <p:spPr>
+          <a:xfrm>
+            <a:off x="914400" y="5532120"/>
+            <a:ext cx="2304288" cy="365760"/>
+          </a:xfrm>
+          <a:prstGeom prst="rect">
+            <a:avLst/>
+          </a:prstGeom>
+          <a:noFill/>
+          <a:ln/>
+        </p:spPr>
+        <p:txBody>
+          <a:bodyPr wrap="square" lIns="0" tIns="0" rIns="0" bIns="0" rtlCol="0" anchor="ctr"/>
+          <a:lstStyle/>
+          <a:p>
+            <a:pPr indent="0" marL="0">
+              <a:buNone/>
+            </a:pPr>
+            <a:r>
+              <a:rPr lang="en-US" sz="1000" dirty="0">
+                <a:solidFill>
+                  <a:srgbClr val="1A2B19"/>
+                </a:solidFill>
+                <a:latin typeface="Calibri" pitchFamily="34" charset="0"/>
+                <a:ea typeface="Calibri" pitchFamily="34" charset="-122"/>
+                <a:cs typeface="Calibri" pitchFamily="34" charset="-120"/>
+              </a:rPr>
+              <a:t>Re-import utility. Safety net for the rest of M6.</a:t>
+            </a:r>
+            <a:endParaRPr lang="en-US" sz="1000" dirty="0"/>
+          </a:p>
+        </p:txBody>
+      </p:sp>
+      <p:sp>
+        <p:nvSpPr>
+          <p:cNvPr id="17" name="Shape 15"/>
+          <p:cNvSpPr/>
+          <p:nvPr/>
+        </p:nvSpPr>
+        <p:spPr>
+          <a:xfrm>
+            <a:off x="3538728" y="4937760"/>
+            <a:ext cx="2670048" cy="960120"/>
+          </a:xfrm>
+          <a:prstGeom prst="rect">
+            <a:avLst/>
+          </a:prstGeom>
+          <a:solidFill>
+            <a:srgbClr val="EBE3D0"/>
+          </a:solidFill>
+          <a:ln w="12700">
+            <a:solidFill>
+              <a:srgbClr val="5A7A4F"/>
+            </a:solidFill>
+            <a:prstDash val="solid"/>
+          </a:ln>
+        </p:spPr>
+      </p:sp>
+      <p:sp>
+        <p:nvSpPr>
+          <p:cNvPr id="18" name="Text 16"/>
+          <p:cNvSpPr/>
+          <p:nvPr/>
+        </p:nvSpPr>
+        <p:spPr>
+          <a:xfrm>
+            <a:off x="3721608" y="5029200"/>
+            <a:ext cx="2304288" cy="274320"/>
+          </a:xfrm>
+          <a:prstGeom prst="rect">
+            <a:avLst/>
+          </a:prstGeom>
+          <a:noFill/>
+          <a:ln/>
+        </p:spPr>
+        <p:txBody>
+          <a:bodyPr wrap="square" lIns="0" tIns="0" rIns="0" bIns="0" rtlCol="0" anchor="ctr"/>
+          <a:lstStyle/>
+          <a:p>
+            <a:pPr indent="0" marL="0">
+              <a:buNone/>
+            </a:pPr>
+            <a:r>
+              <a:rPr lang="en-US" sz="1000" b="1" spc="400" kern="0" dirty="0">
+                <a:solidFill>
+                  <a:srgbClr val="D4A5A5"/>
+                </a:solidFill>
+                <a:latin typeface="Calibri" pitchFamily="34" charset="0"/>
+                <a:ea typeface="Calibri" pitchFamily="34" charset="-122"/>
+                <a:cs typeface="Calibri" pitchFamily="34" charset="-120"/>
+              </a:rPr>
+              <a:t>SESSION 2</a:t>
+            </a:r>
+            <a:endParaRPr lang="en-US" sz="1000" dirty="0"/>
+          </a:p>
+        </p:txBody>
+      </p:sp>
+      <p:sp>
+        <p:nvSpPr>
+          <p:cNvPr id="19" name="Text 17"/>
+          <p:cNvSpPr/>
+          <p:nvPr/>
+        </p:nvSpPr>
+        <p:spPr>
+          <a:xfrm>
+            <a:off x="3721608" y="5257800"/>
+            <a:ext cx="2304288" cy="274320"/>
+          </a:xfrm>
+          <a:prstGeom prst="rect">
+            <a:avLst/>
+          </a:prstGeom>
+          <a:noFill/>
+          <a:ln/>
+        </p:spPr>
+        <p:txBody>
+          <a:bodyPr wrap="square" lIns="0" tIns="0" rIns="0" bIns="0" rtlCol="0" anchor="ctr"/>
+          <a:lstStyle/>
+          <a:p>
+            <a:pPr indent="0" marL="0">
+              <a:buNone/>
+            </a:pPr>
+            <a:r>
+              <a:rPr lang="en-US" sz="1300" b="1" dirty="0">
+                <a:solidFill>
+                  <a:srgbClr val="2D4A2B"/>
+                </a:solidFill>
+                <a:latin typeface="Calibri" pitchFamily="34" charset="0"/>
+                <a:ea typeface="Calibri" pitchFamily="34" charset="-122"/>
+                <a:cs typeface="Calibri" pitchFamily="34" charset="-120"/>
+              </a:rPr>
+              <a:t>Backend + Explore basic</a:t>
+            </a:r>
+            <a:endParaRPr lang="en-US" sz="1300" dirty="0"/>
+          </a:p>
+        </p:txBody>
+      </p:sp>
+      <p:sp>
+        <p:nvSpPr>
+          <p:cNvPr id="20" name="Text 18"/>
+          <p:cNvSpPr/>
+          <p:nvPr/>
+        </p:nvSpPr>
+        <p:spPr>
+          <a:xfrm>
+            <a:off x="3721608" y="5532120"/>
+            <a:ext cx="2304288" cy="365760"/>
+          </a:xfrm>
+          <a:prstGeom prst="rect">
+            <a:avLst/>
+          </a:prstGeom>
+          <a:noFill/>
+          <a:ln/>
+        </p:spPr>
+        <p:txBody>
+          <a:bodyPr wrap="square" lIns="0" tIns="0" rIns="0" bIns="0" rtlCol="0" anchor="ctr"/>
+          <a:lstStyle/>
+          <a:p>
+            <a:pPr indent="0" marL="0">
+              <a:buNone/>
+            </a:pPr>
+            <a:r>
+              <a:rPr lang="en-US" sz="1000" dirty="0">
+                <a:solidFill>
+                  <a:srgbClr val="1A2B19"/>
+                </a:solidFill>
+                <a:latin typeface="Calibri" pitchFamily="34" charset="0"/>
+                <a:ea typeface="Calibri" pitchFamily="34" charset="-122"/>
+                <a:cs typeface="Calibri" pitchFamily="34" charset="-120"/>
+              </a:rPr>
+              <a:t>EXIF, pagination, plot schema, basic /explore route.</a:t>
+            </a:r>
+            <a:endParaRPr lang="en-US" sz="1000" dirty="0"/>
+          </a:p>
+        </p:txBody>
+      </p:sp>
+      <p:sp>
+        <p:nvSpPr>
+          <p:cNvPr id="21" name="Shape 19"/>
+          <p:cNvSpPr/>
+          <p:nvPr/>
+        </p:nvSpPr>
+        <p:spPr>
+          <a:xfrm>
+            <a:off x="6345936" y="4937760"/>
+            <a:ext cx="2670048" cy="960120"/>
+          </a:xfrm>
+          <a:prstGeom prst="rect">
+            <a:avLst/>
+          </a:prstGeom>
+          <a:solidFill>
+            <a:srgbClr val="EBE3D0"/>
+          </a:solidFill>
+          <a:ln w="12700">
+            <a:solidFill>
+              <a:srgbClr val="5A7A4F"/>
+            </a:solidFill>
+            <a:prstDash val="solid"/>
+          </a:ln>
+        </p:spPr>
+      </p:sp>
+      <p:sp>
+        <p:nvSpPr>
+          <p:cNvPr id="22" name="Text 20"/>
+          <p:cNvSpPr/>
+          <p:nvPr/>
+        </p:nvSpPr>
+        <p:spPr>
+          <a:xfrm>
+            <a:off x="6528816" y="5029200"/>
+            <a:ext cx="2304288" cy="274320"/>
+          </a:xfrm>
+          <a:prstGeom prst="rect">
+            <a:avLst/>
+          </a:prstGeom>
+          <a:noFill/>
+          <a:ln/>
+        </p:spPr>
+        <p:txBody>
+          <a:bodyPr wrap="square" lIns="0" tIns="0" rIns="0" bIns="0" rtlCol="0" anchor="ctr"/>
+          <a:lstStyle/>
+          <a:p>
+            <a:pPr indent="0" marL="0">
+              <a:buNone/>
+            </a:pPr>
+            <a:r>
+              <a:rPr lang="en-US" sz="1000" b="1" spc="400" kern="0" dirty="0">
+                <a:solidFill>
+                  <a:srgbClr val="D4A5A5"/>
+                </a:solidFill>
+                <a:latin typeface="Calibri" pitchFamily="34" charset="0"/>
+                <a:ea typeface="Calibri" pitchFamily="34" charset="-122"/>
+                <a:cs typeface="Calibri" pitchFamily="34" charset="-120"/>
+              </a:rPr>
+              <a:t>SESSION 3</a:t>
+            </a:r>
+            <a:endParaRPr lang="en-US" sz="1000" dirty="0"/>
+          </a:p>
+        </p:txBody>
+      </p:sp>
+      <p:sp>
+        <p:nvSpPr>
+          <p:cNvPr id="23" name="Text 21"/>
+          <p:cNvSpPr/>
+          <p:nvPr/>
+        </p:nvSpPr>
+        <p:spPr>
+          <a:xfrm>
+            <a:off x="6528816" y="5257800"/>
+            <a:ext cx="2304288" cy="274320"/>
+          </a:xfrm>
+          <a:prstGeom prst="rect">
+            <a:avLst/>
+          </a:prstGeom>
+          <a:noFill/>
+          <a:ln/>
+        </p:spPr>
+        <p:txBody>
+          <a:bodyPr wrap="square" lIns="0" tIns="0" rIns="0" bIns="0" rtlCol="0" anchor="ctr"/>
+          <a:lstStyle/>
+          <a:p>
+            <a:pPr indent="0" marL="0">
+              <a:buNone/>
+            </a:pPr>
+            <a:r>
+              <a:rPr lang="en-US" sz="1300" b="1" dirty="0">
+                <a:solidFill>
+                  <a:srgbClr val="2D4A2B"/>
+                </a:solidFill>
+                <a:latin typeface="Calibri" pitchFamily="34" charset="0"/>
+                <a:ea typeface="Calibri" pitchFamily="34" charset="-122"/>
+                <a:cs typeface="Calibri" pitchFamily="34" charset="-120"/>
+              </a:rPr>
+              <a:t>Web complete</a:t>
+            </a:r>
+            <a:endParaRPr lang="en-US" sz="1300" dirty="0"/>
+          </a:p>
+        </p:txBody>
+      </p:sp>
+      <p:sp>
+        <p:nvSpPr>
+          <p:cNvPr id="24" name="Text 22"/>
+          <p:cNvSpPr/>
+          <p:nvPr/>
+        </p:nvSpPr>
+        <p:spPr>
+          <a:xfrm>
+            <a:off x="6528816" y="5532120"/>
+            <a:ext cx="2304288" cy="365760"/>
+          </a:xfrm>
+          <a:prstGeom prst="rect">
+            <a:avLst/>
+          </a:prstGeom>
+          <a:noFill/>
+          <a:ln/>
+        </p:spPr>
+        <p:txBody>
+          <a:bodyPr wrap="square" lIns="0" tIns="0" rIns="0" bIns="0" rtlCol="0" anchor="ctr"/>
+          <a:lstStyle/>
+          <a:p>
+            <a:pPr indent="0" marL="0">
+              <a:buNone/>
+            </a:pPr>
+            <a:r>
+              <a:rPr lang="en-US" sz="1000" dirty="0">
+                <a:solidFill>
+                  <a:srgbClr val="1A2B19"/>
+                </a:solidFill>
+                <a:latin typeface="Calibri" pitchFamily="34" charset="0"/>
+                <a:ea typeface="Calibri" pitchFamily="34" charset="-122"/>
+                <a:cs typeface="Calibri" pitchFamily="34" charset="-120"/>
+              </a:rPr>
+              <a:t>Filters, Garden plots, photo detail variants. Flat-Garden retires.</a:t>
+            </a:r>
+            <a:endParaRPr lang="en-US" sz="1000" dirty="0"/>
+          </a:p>
+        </p:txBody>
+      </p:sp>
+      <p:sp>
+        <p:nvSpPr>
+          <p:cNvPr id="25" name="Shape 23"/>
+          <p:cNvSpPr/>
+          <p:nvPr/>
+        </p:nvSpPr>
+        <p:spPr>
+          <a:xfrm>
+            <a:off x="9153144" y="4937760"/>
+            <a:ext cx="2670048" cy="960120"/>
+          </a:xfrm>
+          <a:prstGeom prst="rect">
+            <a:avLst/>
+          </a:prstGeom>
+          <a:solidFill>
+            <a:srgbClr val="EBE3D0"/>
+          </a:solidFill>
+          <a:ln w="12700">
+            <a:solidFill>
+              <a:srgbClr val="5A7A4F"/>
+            </a:solidFill>
+            <a:prstDash val="solid"/>
+          </a:ln>
+        </p:spPr>
+      </p:sp>
+      <p:sp>
+        <p:nvSpPr>
+          <p:cNvPr id="26" name="Text 24"/>
+          <p:cNvSpPr/>
+          <p:nvPr/>
+        </p:nvSpPr>
+        <p:spPr>
+          <a:xfrm>
+            <a:off x="9336024" y="5029200"/>
+            <a:ext cx="2304288" cy="274320"/>
+          </a:xfrm>
+          <a:prstGeom prst="rect">
+            <a:avLst/>
+          </a:prstGeom>
+          <a:noFill/>
+          <a:ln/>
+        </p:spPr>
+        <p:txBody>
+          <a:bodyPr wrap="square" lIns="0" tIns="0" rIns="0" bIns="0" rtlCol="0" anchor="ctr"/>
+          <a:lstStyle/>
+          <a:p>
+            <a:pPr indent="0" marL="0">
+              <a:buNone/>
+            </a:pPr>
+            <a:r>
+              <a:rPr lang="en-US" sz="1000" b="1" spc="400" kern="0" dirty="0">
+                <a:solidFill>
+                  <a:srgbClr val="D4A5A5"/>
+                </a:solidFill>
+                <a:latin typeface="Calibri" pitchFamily="34" charset="0"/>
+                <a:ea typeface="Calibri" pitchFamily="34" charset="-122"/>
+                <a:cs typeface="Calibri" pitchFamily="34" charset="-120"/>
+              </a:rPr>
+              <a:t>SESSION 4</a:t>
+            </a:r>
+            <a:endParaRPr lang="en-US" sz="1000" dirty="0"/>
+          </a:p>
+        </p:txBody>
+      </p:sp>
+      <p:sp>
+        <p:nvSpPr>
+          <p:cNvPr id="27" name="Text 25"/>
+          <p:cNvSpPr/>
+          <p:nvPr/>
+        </p:nvSpPr>
+        <p:spPr>
+          <a:xfrm>
+            <a:off x="9336024" y="5257800"/>
+            <a:ext cx="2304288" cy="274320"/>
+          </a:xfrm>
+          <a:prstGeom prst="rect">
+            <a:avLst/>
+          </a:prstGeom>
+          <a:noFill/>
+          <a:ln/>
+        </p:spPr>
+        <p:txBody>
+          <a:bodyPr wrap="square" lIns="0" tIns="0" rIns="0" bIns="0" rtlCol="0" anchor="ctr"/>
+          <a:lstStyle/>
+          <a:p>
+            <a:pPr indent="0" marL="0">
+              <a:buNone/>
+            </a:pPr>
+            <a:r>
+              <a:rPr lang="en-US" sz="1300" b="1" dirty="0">
+                <a:solidFill>
+                  <a:srgbClr val="2D4A2B"/>
+                </a:solidFill>
+                <a:latin typeface="Calibri" pitchFamily="34" charset="0"/>
+                <a:ea typeface="Calibri" pitchFamily="34" charset="-122"/>
+                <a:cs typeface="Calibri" pitchFamily="34" charset="-120"/>
+              </a:rPr>
+              <a:t>Android adoption</a:t>
+            </a:r>
+            <a:endParaRPr lang="en-US" sz="1300" dirty="0"/>
+          </a:p>
+        </p:txBody>
+      </p:sp>
+      <p:sp>
+        <p:nvSpPr>
+          <p:cNvPr id="28" name="Text 26"/>
+          <p:cNvSpPr/>
+          <p:nvPr/>
+        </p:nvSpPr>
+        <p:spPr>
+          <a:xfrm>
+            <a:off x="9336024" y="5532120"/>
+            <a:ext cx="2304288" cy="365760"/>
+          </a:xfrm>
+          <a:prstGeom prst="rect">
+            <a:avLst/>
+          </a:prstGeom>
+          <a:noFill/>
+          <a:ln/>
+        </p:spPr>
+        <p:txBody>
+          <a:bodyPr wrap="square" lIns="0" tIns="0" rIns="0" bIns="0" rtlCol="0" anchor="ctr"/>
+          <a:lstStyle/>
+          <a:p>
+            <a:pPr indent="0" marL="0">
+              <a:buNone/>
+            </a:pPr>
+            <a:r>
+              <a:rPr lang="en-US" sz="1000" dirty="0">
+                <a:solidFill>
+                  <a:srgbClr val="1A2B19"/>
+                </a:solidFill>
+                <a:latin typeface="Calibri" pitchFamily="34" charset="0"/>
+                <a:ea typeface="Calibri" pitchFamily="34" charset="-122"/>
+                <a:cs typeface="Calibri" pitchFamily="34" charset="-120"/>
+              </a:rPr>
+              <a:t>Explore tab, Garden plots, burger-menu nav.</a:t>
+            </a:r>
+            <a:endParaRPr lang="en-US" sz="1000" dirty="0"/>
+          </a:p>
+        </p:txBody>
+      </p:sp>
+      <p:sp>
+        <p:nvSpPr>
+          <p:cNvPr id="29" name="Text 27"/>
+          <p:cNvSpPr/>
+          <p:nvPr/>
+        </p:nvSpPr>
+        <p:spPr>
+          <a:xfrm>
+            <a:off x="731520" y="6263640"/>
+            <a:ext cx="10972800" cy="365760"/>
+          </a:xfrm>
+          <a:prstGeom prst="rect">
+            <a:avLst/>
+          </a:prstGeom>
+          <a:noFill/>
+          <a:ln/>
+        </p:spPr>
+        <p:txBody>
+          <a:bodyPr wrap="square" lIns="0" tIns="0" rIns="0" bIns="0" rtlCol="0" anchor="ctr"/>
+          <a:lstStyle/>
+          <a:p>
+            <a:pPr algn="l" indent="0" marL="0">
+              <a:buNone/>
+            </a:pPr>
+            <a:r>
+              <a:rPr lang="en-US" sz="1100" i="1" dirty="0">
+                <a:solidFill>
+                  <a:srgbClr val="6B7B68"/>
+                </a:solidFill>
+                <a:latin typeface="Calibri" pitchFamily="34" charset="0"/>
+                <a:ea typeface="Calibri" pitchFamily="34" charset="-122"/>
+                <a:cs typeface="Calibri" pitchFamily="34" charset="-120"/>
+              </a:rPr>
+              <a:t>Founder owning context across sessions; tight scoping; AI doing the typing while the founder steers. The multiplier is perceived for this product and team, not a benchmarked claim.</a:t>
+            </a:r>
+            <a:endParaRPr lang="en-US" sz="1100" dirty="0"/>
+          </a:p>
+        </p:txBody>
+      </p:sp>
+    </p:spTree>
+  </p:cSld>
+  <p:clrMapOvr>
+    <a:masterClrMapping/>
+  </p:clrMapOvr>
+</p:sld>
+</file>
+
+<file path=ppt/slides/slide13.xml><?xml version="1.0" encoding="utf-8"?>
+<p:sld xmlns:a="http://schemas.openxmlformats.org/drawingml/2006/main" xmlns:r="http://schemas.openxmlformats.org/officeDocument/2006/relationships" xmlns:p="http://schemas.openxmlformats.org/presentationml/2006/main">
+  <p:cSld name="Slide 13">
     <p:bg>
       <p:bgPr>
         <a:solidFill>
@@ -7836,7 +9031,7 @@
                 <a:ea typeface="Calibri" pitchFamily="34" charset="-122"/>
                 <a:cs typeface="Calibri" pitchFamily="34" charset="-120"/>
               </a:rPr>
-              <a:t>Four phases, three streams, twelve incremental briefs.</a:t>
+              <a:t>Four deliverables, ~3-4 days total. Tools first as a safety net.</a:t>
             </a:r>
             <a:endParaRPr lang="en-US" sz="1600" dirty="0"/>
           </a:p>
@@ -7959,7 +9154,7 @@
                 <a:ea typeface="Calibri" pitchFamily="34" charset="-122"/>
                 <a:cs typeface="Calibri" pitchFamily="34" charset="-120"/>
               </a:rPr>
-              <a:t>BACKEND</a:t>
+              <a:t>~1 DAY</a:t>
             </a:r>
             <a:endParaRPr lang="en-US" sz="900" dirty="0"/>
           </a:p>
@@ -7998,7 +9193,7 @@
                 <a:ea typeface="Calibri" pitchFamily="34" charset="-122"/>
                 <a:cs typeface="Calibri" pitchFamily="34" charset="-120"/>
               </a:rPr>
-              <a:t>Backend foundations</a:t>
+              <a:t>Tools</a:t>
             </a:r>
             <a:endParaRPr lang="en-US" sz="1400" dirty="0"/>
           </a:p>
@@ -8037,7 +9232,7 @@
                 <a:ea typeface="Calibri" pitchFamily="34" charset="-122"/>
                 <a:cs typeface="Calibri" pitchFamily="34" charset="-120"/>
               </a:rPr>
-              <a:t>EXIF extraction (background job). Pagination on list endpoints. Plot schema and endpoints.</a:t>
+              <a:t>Re-import utility. Scan GCS, hash content, recreate uploads rows. A safety net for the rest of M6.</a:t>
             </a:r>
             <a:endParaRPr lang="en-US" sz="1200" dirty="0"/>
           </a:p>
@@ -8224,7 +9419,7 @@
                 <a:ea typeface="Calibri" pitchFamily="34" charset="-122"/>
                 <a:cs typeface="Calibri" pitchFamily="34" charset="-120"/>
               </a:rPr>
-              <a:t>WEB</a:t>
+              <a:t>~1 DAY</a:t>
             </a:r>
             <a:endParaRPr lang="en-US" sz="900" dirty="0"/>
           </a:p>
@@ -8263,7 +9458,7 @@
                 <a:ea typeface="Calibri" pitchFamily="34" charset="-122"/>
                 <a:cs typeface="Calibri" pitchFamily="34" charset="-120"/>
               </a:rPr>
-              <a:t>Web Explore tab</a:t>
+              <a:t>Backend + Explore basic</a:t>
             </a:r>
             <a:endParaRPr lang="en-US" sz="1400" dirty="0"/>
           </a:p>
@@ -8302,7 +9497,7 @@
                 <a:ea typeface="Calibri" pitchFamily="34" charset="-122"/>
                 <a:cs typeface="Calibri" pitchFamily="34" charset="-120"/>
               </a:rPr>
-              <a:t>New /explore route. Tag/date/composted filters. Photo detail variant emphasising content.</a:t>
+              <a:t>EXIF extraction. Pagination. Plot schema. New /explore route with paginated grid.</a:t>
             </a:r>
             <a:endParaRPr lang="en-US" sz="1200" dirty="0"/>
           </a:p>
@@ -8489,7 +9684,7 @@
                 <a:ea typeface="Calibri" pitchFamily="34" charset="-122"/>
                 <a:cs typeface="Calibri" pitchFamily="34" charset="-120"/>
               </a:rPr>
-              <a:t>WEB</a:t>
+              <a:t>~1-1.5 DAYS</a:t>
             </a:r>
             <a:endParaRPr lang="en-US" sz="900" dirty="0"/>
           </a:p>
@@ -8528,7 +9723,7 @@
                 <a:ea typeface="Calibri" pitchFamily="34" charset="-122"/>
                 <a:cs typeface="Calibri" pitchFamily="34" charset="-120"/>
               </a:rPr>
-              <a:t>Web Garden plots</a:t>
+              <a:t>Web complete</a:t>
             </a:r>
             <a:endParaRPr lang="en-US" sz="1400" dirty="0"/>
           </a:p>
@@ -8567,7 +9762,7 @@
                 <a:ea typeface="Calibri" pitchFamily="34" charset="-122"/>
                 <a:cs typeface="Calibri" pitchFamily="34" charset="-120"/>
               </a:rPr>
-              <a:t>Just arrived plot (mandatory). User plot management. Photo detail variant emphasising actions.</a:t>
+              <a:t>Explore filters and sort. Garden plots restructure. Photo detail variants per surface.</a:t>
             </a:r>
             <a:endParaRPr lang="en-US" sz="1200" dirty="0"/>
           </a:p>
@@ -8754,7 +9949,7 @@
                 <a:ea typeface="Calibri" pitchFamily="34" charset="-122"/>
                 <a:cs typeface="Calibri" pitchFamily="34" charset="-120"/>
               </a:rPr>
-              <a:t>ANDROID</a:t>
+              <a:t>~1 DAY</a:t>
             </a:r>
             <a:endParaRPr lang="en-US" sz="900" dirty="0"/>
           </a:p>
@@ -8967,7 +10162,7 @@
                 <a:ea typeface="Calibri" pitchFamily="34" charset="-122"/>
                 <a:cs typeface="Calibri" pitchFamily="34" charset="-120"/>
               </a:rPr>
-              <a:t>Phase 1</a:t>
+              <a:t>Deliverable 1</a:t>
             </a:r>
             <a:endParaRPr lang="en-US" sz="1200" dirty="0"/>
           </a:p>
@@ -9006,7 +10201,7 @@
                 <a:ea typeface="Georgia" pitchFamily="34" charset="-122"/>
                 <a:cs typeface="Georgia" pitchFamily="34" charset="-120"/>
               </a:rPr>
-              <a:t>Backend foundations</a:t>
+              <a:t>Tools — re-import utility</a:t>
             </a:r>
             <a:endParaRPr lang="en-US" sz="3600" dirty="0"/>
           </a:p>
@@ -9045,7 +10240,7 @@
                 <a:ea typeface="Calibri" pitchFamily="34" charset="-122"/>
                 <a:cs typeface="Calibri" pitchFamily="34" charset="-120"/>
               </a:rPr>
-              <a:t>No UI changes. Existing web continues to work; v0.21.0 Android ships unaffected.</a:t>
+              <a:t>Independent of the rest of M6. Built first as a safety net: with this in place, the rest of the work can experiment freely with the schema and data.</a:t>
             </a:r>
             <a:endParaRPr lang="en-US" sz="1600" dirty="0"/>
           </a:p>
@@ -9168,7 +10363,7 @@
                 <a:ea typeface="Calibri" pitchFamily="34" charset="-122"/>
                 <a:cs typeface="Calibri" pitchFamily="34" charset="-120"/>
               </a:rPr>
-              <a:t>EXIF extraction</a:t>
+              <a:t>Scan and import</a:t>
             </a:r>
             <a:endParaRPr lang="en-US" sz="1400" dirty="0"/>
           </a:p>
@@ -9207,7 +10402,7 @@
                 <a:ea typeface="Calibri" pitchFamily="34" charset="-122"/>
                 <a:cs typeface="Calibri" pitchFamily="34" charset="-120"/>
               </a:rPr>
-              <a:t>Background job on upload. Adds taken-date and location lat/lng to uploads. Item appears in Garden immediately; metadata populates asynchronously.</a:t>
+              <a:t>Standalone script lists every object in the GCS bucket, computes SHA256, and INSERTs an uploads row for each. Content stays in place; rows reference existing GCS keys.</a:t>
             </a:r>
             <a:endParaRPr lang="en-US" sz="1200" dirty="0"/>
           </a:p>
@@ -9246,7 +10441,7 @@
                 <a:ea typeface="Calibri" pitchFamily="34" charset="-122"/>
                 <a:cs typeface="Calibri" pitchFamily="34" charset="-120"/>
               </a:rPr>
-              <a:t>≈ 2 days</a:t>
+              <a:t>≈ 0.5 day</a:t>
             </a:r>
             <a:endParaRPr lang="en-US" sz="1100" dirty="0"/>
           </a:p>
@@ -9369,7 +10564,7 @@
                 <a:ea typeface="Calibri" pitchFamily="34" charset="-122"/>
                 <a:cs typeface="Calibri" pitchFamily="34" charset="-120"/>
               </a:rPr>
-              <a:t>Pagination</a:t>
+              <a:t>Trigger and verify</a:t>
             </a:r>
             <a:endParaRPr lang="en-US" sz="1400" dirty="0"/>
           </a:p>
@@ -9408,7 +10603,7 @@
                 <a:ea typeface="Calibri" pitchFamily="34" charset="-122"/>
                 <a:cs typeface="Calibri" pitchFamily="34" charset="-120"/>
               </a:rPr>
-              <a:t>Cursor-based pagination on list endpoints. Backwards-compatible — existing un-paginated callers receive first page; clients migrate gradually.</a:t>
+              <a:t>Fires EXIF backfill jobs for imported rows (no-op if EXIF hasn't shipped yet). Verifies counts match GCS object count. Sample integrity check.</a:t>
             </a:r>
             <a:endParaRPr lang="en-US" sz="1200" dirty="0"/>
           </a:p>
@@ -9447,7 +10642,7 @@
                 <a:ea typeface="Calibri" pitchFamily="34" charset="-122"/>
                 <a:cs typeface="Calibri" pitchFamily="34" charset="-120"/>
               </a:rPr>
-              <a:t>≈ 2 days</a:t>
+              <a:t>≈ 0.25 day</a:t>
             </a:r>
             <a:endParaRPr lang="en-US" sz="1100" dirty="0"/>
           </a:p>
@@ -9570,7 +10765,7 @@
                 <a:ea typeface="Calibri" pitchFamily="34" charset="-122"/>
                 <a:cs typeface="Calibri" pitchFamily="34" charset="-120"/>
               </a:rPr>
-              <a:t>Plot schema and endpoints</a:t>
+              <a:t>Document</a:t>
             </a:r>
             <a:endParaRPr lang="en-US" sz="1400" dirty="0"/>
           </a:p>
@@ -9609,7 +10804,7 @@
                 <a:ea typeface="Calibri" pitchFamily="34" charset="-122"/>
                 <a:cs typeface="Calibri" pitchFamily="34" charset="-120"/>
               </a:rPr>
-              <a:t>New tables for plot definitions and per-user configuration. "Just arrived" is system-defined; user-defined plots layer on top. Sort/filter API additions.</a:t>
+              <a:t>Runbook in PA_NOTES.md: how to nuke the database safely, run the script, and confirm recovery. Bret can do this without re-uploading.</a:t>
             </a:r>
             <a:endParaRPr lang="en-US" sz="1200" dirty="0"/>
           </a:p>
@@ -9648,7 +10843,7 @@
                 <a:ea typeface="Calibri" pitchFamily="34" charset="-122"/>
                 <a:cs typeface="Calibri" pitchFamily="34" charset="-120"/>
               </a:rPr>
-              <a:t>≈ 3 days</a:t>
+              <a:t>≈ 0.25 day</a:t>
             </a:r>
             <a:endParaRPr lang="en-US" sz="1100" dirty="0"/>
           </a:p>
@@ -9687,7 +10882,7 @@
                 <a:ea typeface="Calibri" pitchFamily="34" charset="-122"/>
                 <a:cs typeface="Calibri" pitchFamily="34" charset="-120"/>
               </a:rPr>
-              <a:t>Stream: Backend  ·  Cadence: 3 increments, each independently shippable</a:t>
+              <a:t>Three sub-tasks · Shipped as one focused session</a:t>
             </a:r>
             <a:endParaRPr lang="en-US" sz="1100" dirty="0"/>
           </a:p>
@@ -9758,7 +10953,7 @@
                 <a:ea typeface="Calibri" pitchFamily="34" charset="-122"/>
                 <a:cs typeface="Calibri" pitchFamily="34" charset="-120"/>
               </a:rPr>
-              <a:t>Phase 2</a:t>
+              <a:t>Deliverable 2</a:t>
             </a:r>
             <a:endParaRPr lang="en-US" sz="1200" dirty="0"/>
           </a:p>
@@ -9797,7 +10992,7 @@
                 <a:ea typeface="Georgia" pitchFamily="34" charset="-122"/>
                 <a:cs typeface="Georgia" pitchFamily="34" charset="-120"/>
               </a:rPr>
-              <a:t>Web Explore tab</a:t>
+              <a:t>Backend + Explore basic</a:t>
             </a:r>
             <a:endParaRPr lang="en-US" sz="3600" dirty="0"/>
           </a:p>
@@ -9836,7 +11031,7 @@
                 <a:ea typeface="Calibri" pitchFamily="34" charset="-122"/>
                 <a:cs typeface="Calibri" pitchFamily="34" charset="-120"/>
               </a:rPr>
-              <a:t>Built first because it's mostly additive. New tab, new page; Garden's existing behaviour unchanged during this phase.</a:t>
+              <a:t>All backend foundations plus the simplest possible Explore route. Garden's existing flat behaviour unchanged during this deliverable.</a:t>
             </a:r>
             <a:endParaRPr lang="en-US" sz="1600" dirty="0"/>
           </a:p>
@@ -9959,7 +11154,7 @@
                 <a:ea typeface="Calibri" pitchFamily="34" charset="-122"/>
                 <a:cs typeface="Calibri" pitchFamily="34" charset="-120"/>
               </a:rPr>
-              <a:t>Explore page basic</a:t>
+              <a:t>EXIF extraction</a:t>
             </a:r>
             <a:endParaRPr lang="en-US" sz="1400" dirty="0"/>
           </a:p>
@@ -9998,7 +11193,7 @@
                 <a:ea typeface="Calibri" pitchFamily="34" charset="-122"/>
                 <a:cs typeface="Calibri" pitchFamily="34" charset="-120"/>
               </a:rPr>
-              <a:t>New /explore route. Paginated grid of all active items, newest-first by upload date. Tag filter chrome reused from existing Garden.</a:t>
+              <a:t>Background job on upload. Adds taken-date and location lat/lng columns to uploads (nullable). Item appears immediately; metadata populates asynchronously.</a:t>
             </a:r>
             <a:endParaRPr lang="en-US" sz="1200" dirty="0"/>
           </a:p>
@@ -10037,7 +11232,7 @@
                 <a:ea typeface="Calibri" pitchFamily="34" charset="-122"/>
                 <a:cs typeface="Calibri" pitchFamily="34" charset="-120"/>
               </a:rPr>
-              <a:t>≈ 2-3 days</a:t>
+              <a:t>≈ 0.4 day</a:t>
             </a:r>
             <a:endParaRPr lang="en-US" sz="1100" dirty="0"/>
           </a:p>
@@ -10160,7 +11355,7 @@
                 <a:ea typeface="Calibri" pitchFamily="34" charset="-122"/>
                 <a:cs typeface="Calibri" pitchFamily="34" charset="-120"/>
               </a:rPr>
-              <a:t>Explore filters</a:t>
+              <a:t>Pagination + /explore</a:t>
             </a:r>
             <a:endParaRPr lang="en-US" sz="1400" dirty="0"/>
           </a:p>
@@ -10199,7 +11394,7 @@
                 <a:ea typeface="Calibri" pitchFamily="34" charset="-122"/>
                 <a:cs typeface="Calibri" pitchFamily="34" charset="-120"/>
               </a:rPr>
-              <a:t>Date range, capsule membership, composted toggle, location-boolean filter. Sort options (full set with EXIF indicator).</a:t>
+              <a:t>Cursor-based pagination on list endpoints. New /explore route serving a paginated grid, newest-first by upload date. No filters yet.</a:t>
             </a:r>
             <a:endParaRPr lang="en-US" sz="1200" dirty="0"/>
           </a:p>
@@ -10238,7 +11433,7 @@
                 <a:ea typeface="Calibri" pitchFamily="34" charset="-122"/>
                 <a:cs typeface="Calibri" pitchFamily="34" charset="-120"/>
               </a:rPr>
-              <a:t>≈ 2-3 days</a:t>
+              <a:t>≈ 0.3 day</a:t>
             </a:r>
             <a:endParaRPr lang="en-US" sz="1100" dirty="0"/>
           </a:p>
@@ -10361,7 +11556,7 @@
                 <a:ea typeface="Calibri" pitchFamily="34" charset="-122"/>
                 <a:cs typeface="Calibri" pitchFamily="34" charset="-120"/>
               </a:rPr>
-              <a:t>Explore photo detail variant</a:t>
+              <a:t>Plot schema</a:t>
             </a:r>
             <a:endParaRPr lang="en-US" sz="1400" dirty="0"/>
           </a:p>
@@ -10400,7 +11595,7 @@
                 <a:ea typeface="Calibri" pitchFamily="34" charset="-122"/>
                 <a:cs typeface="Calibri" pitchFamily="34" charset="-120"/>
               </a:rPr>
-              <a:t>Photo detail when entered from Explore emphasises content presentation over actions. Action affordances secondary.</a:t>
+              <a:t>New tables for plot definitions and per-user configuration. "Just arrived" is system-defined; user-defined plots layer on top. Sort/filter API additions.</a:t>
             </a:r>
             <a:endParaRPr lang="en-US" sz="1200" dirty="0"/>
           </a:p>
@@ -10439,7 +11634,7 @@
                 <a:ea typeface="Calibri" pitchFamily="34" charset="-122"/>
                 <a:cs typeface="Calibri" pitchFamily="34" charset="-120"/>
               </a:rPr>
-              <a:t>≈ 1-2 days</a:t>
+              <a:t>≈ 0.3 day</a:t>
             </a:r>
             <a:endParaRPr lang="en-US" sz="1100" dirty="0"/>
           </a:p>
@@ -10478,7 +11673,7 @@
                 <a:ea typeface="Calibri" pitchFamily="34" charset="-122"/>
                 <a:cs typeface="Calibri" pitchFamily="34" charset="-120"/>
               </a:rPr>
-              <a:t>Stream: Web  ·  Cadence: 3 increments, each independently shippable</a:t>
+              <a:t>Three sub-tasks · Shipped as one focused session</a:t>
             </a:r>
             <a:endParaRPr lang="en-US" sz="1100" dirty="0"/>
           </a:p>
@@ -10549,7 +11744,7 @@
                 <a:ea typeface="Calibri" pitchFamily="34" charset="-122"/>
                 <a:cs typeface="Calibri" pitchFamily="34" charset="-120"/>
               </a:rPr>
-              <a:t>Phase 3</a:t>
+              <a:t>Deliverable 3</a:t>
             </a:r>
             <a:endParaRPr lang="en-US" sz="1200" dirty="0"/>
           </a:p>
@@ -10588,7 +11783,7 @@
                 <a:ea typeface="Georgia" pitchFamily="34" charset="-122"/>
                 <a:cs typeface="Georgia" pitchFamily="34" charset="-120"/>
               </a:rPr>
-              <a:t>Web Garden plots</a:t>
+              <a:t>Web complete</a:t>
             </a:r>
             <a:endParaRPr lang="en-US" sz="3600" dirty="0"/>
           </a:p>
@@ -10627,7 +11822,7 @@
                 <a:ea typeface="Calibri" pitchFamily="34" charset="-122"/>
                 <a:cs typeface="Calibri" pitchFamily="34" charset="-120"/>
               </a:rPr>
-              <a:t>Riskier — transforms an existing surface. Done after Explore so users have a fallback while Garden is changing shape.</a:t>
+              <a:t>Web fully transitioned to the new Garden / Explore structure. The flat-Garden mental model retires; users learn the new shape.</a:t>
             </a:r>
             <a:endParaRPr lang="en-US" sz="1600" dirty="0"/>
           </a:p>
@@ -10750,7 +11945,7 @@
                 <a:ea typeface="Calibri" pitchFamily="34" charset="-122"/>
                 <a:cs typeface="Calibri" pitchFamily="34" charset="-120"/>
               </a:rPr>
-              <a:t>Just arrived plot</a:t>
+              <a:t>Explore filters and sort</a:t>
             </a:r>
             <a:endParaRPr lang="en-US" sz="1400" dirty="0"/>
           </a:p>
@@ -10789,7 +11984,7 @@
                 <a:ea typeface="Calibri" pitchFamily="34" charset="-122"/>
                 <a:cs typeface="Calibri" pitchFamily="34" charset="-120"/>
               </a:rPr>
-              <a:t>Garden becomes a horizontal-scrolling row of "Just arrived" items at top, with the existing flat grid below as fallback during transition.</a:t>
+              <a:t>Tag, date range, capsule membership, composted toggle, location-boolean. Sort options (newest/oldest by upload, by taken date) with EXIF-availability indicator.</a:t>
             </a:r>
             <a:endParaRPr lang="en-US" sz="1200" dirty="0"/>
           </a:p>
@@ -10828,7 +12023,7 @@
                 <a:ea typeface="Calibri" pitchFamily="34" charset="-122"/>
                 <a:cs typeface="Calibri" pitchFamily="34" charset="-120"/>
               </a:rPr>
-              <a:t>≈ 2-3 days</a:t>
+              <a:t>≈ 0.4 day</a:t>
             </a:r>
             <a:endParaRPr lang="en-US" sz="1100" dirty="0"/>
           </a:p>
@@ -10951,7 +12146,7 @@
                 <a:ea typeface="Calibri" pitchFamily="34" charset="-122"/>
                 <a:cs typeface="Calibri" pitchFamily="34" charset="-120"/>
               </a:rPr>
-              <a:t>User plot management</a:t>
+              <a:t>Garden plots</a:t>
             </a:r>
             <a:endParaRPr lang="en-US" sz="1400" dirty="0"/>
           </a:p>
@@ -10990,7 +12185,7 @@
                 <a:ea typeface="Calibri" pitchFamily="34" charset="-122"/>
                 <a:cs typeface="Calibri" pitchFamily="34" charset="-120"/>
               </a:rPr>
-              <a:t>"Add a plot" affordance. User-created plots with tag-based criteria. Plots appear as additional rows. Fallback flat grid retires.</a:t>
+              <a:t>Garden becomes vertically-stacked horizontal rows. Mandatory "Just arrived" plot at top; user-defined plots below via "Add a plot" affordance with tag-based criteria.</a:t>
             </a:r>
             <a:endParaRPr lang="en-US" sz="1200" dirty="0"/>
           </a:p>
@@ -11029,7 +12224,7 @@
                 <a:ea typeface="Calibri" pitchFamily="34" charset="-122"/>
                 <a:cs typeface="Calibri" pitchFamily="34" charset="-120"/>
               </a:rPr>
-              <a:t>≈ 3-4 days</a:t>
+              <a:t>≈ 0.6 day</a:t>
             </a:r>
             <a:endParaRPr lang="en-US" sz="1100" dirty="0"/>
           </a:p>
@@ -11152,7 +12347,7 @@
                 <a:ea typeface="Calibri" pitchFamily="34" charset="-122"/>
                 <a:cs typeface="Calibri" pitchFamily="34" charset="-120"/>
               </a:rPr>
-              <a:t>Garden photo detail variant</a:t>
+              <a:t>Photo detail variants</a:t>
             </a:r>
             <a:endParaRPr lang="en-US" sz="1400" dirty="0"/>
           </a:p>
@@ -11191,7 +12386,7 @@
                 <a:ea typeface="Calibri" pitchFamily="34" charset="-122"/>
                 <a:cs typeface="Calibri" pitchFamily="34" charset="-120"/>
               </a:rPr>
-              <a:t>Photo detail when entered from Garden emphasises action affordances (compost, tag, add to capsule). Compost heap link stays on Garden.</a:t>
+              <a:t>Detail view differs by entry surface: Garden = action affordances prominent; Explore = content presentation. Compost heap link stays on Garden.</a:t>
             </a:r>
             <a:endParaRPr lang="en-US" sz="1200" dirty="0"/>
           </a:p>
@@ -11230,7 +12425,7 @@
                 <a:ea typeface="Calibri" pitchFamily="34" charset="-122"/>
                 <a:cs typeface="Calibri" pitchFamily="34" charset="-120"/>
               </a:rPr>
-              <a:t>≈ 1-2 days</a:t>
+              <a:t>≈ 0.3-0.5 day</a:t>
             </a:r>
             <a:endParaRPr lang="en-US" sz="1100" dirty="0"/>
           </a:p>
@@ -11269,7 +12464,7 @@
                 <a:ea typeface="Calibri" pitchFamily="34" charset="-122"/>
                 <a:cs typeface="Calibri" pitchFamily="34" charset="-120"/>
               </a:rPr>
-              <a:t>Stream: Web  ·  Cadence: 3 increments, each independently shippable</a:t>
+              <a:t>Three sub-tasks · Shipped as one focused session</a:t>
             </a:r>
             <a:endParaRPr lang="en-US" sz="1100" dirty="0"/>
           </a:p>
@@ -11340,7 +12535,7 @@
                 <a:ea typeface="Calibri" pitchFamily="34" charset="-122"/>
                 <a:cs typeface="Calibri" pitchFamily="34" charset="-120"/>
               </a:rPr>
-              <a:t>Phase 4</a:t>
+              <a:t>Deliverable 4</a:t>
             </a:r>
             <a:endParaRPr lang="en-US" sz="1200" dirty="0"/>
           </a:p>
@@ -11418,7 +12613,7 @@
                 <a:ea typeface="Calibri" pitchFamily="34" charset="-122"/>
                 <a:cs typeface="Calibri" pitchFamily="34" charset="-120"/>
               </a:rPr>
-              <a:t>Android catches up to the new web structure. Includes the bottom-nav restructure (burger menu replacing v0.21.0's three-tab Settings entry).</a:t>
+              <a:t>Android catches up to the new web structure, including the bottom-nav restructure that replaces v0.21.0's three-tab Settings entry.</a:t>
             </a:r>
             <a:endParaRPr lang="en-US" sz="1600" dirty="0"/>
           </a:p>
@@ -11580,7 +12775,7 @@
                 <a:ea typeface="Calibri" pitchFamily="34" charset="-122"/>
                 <a:cs typeface="Calibri" pitchFamily="34" charset="-120"/>
               </a:rPr>
-              <a:t>New tab on Android matching web's Explore. Reuses photo detail components where possible. Pagination via Compose's LazyColumn primitives.</a:t>
+              <a:t>New tab matching web's Explore. Reuses photo detail components where possible. Pagination via Compose's LazyColumn / LazyRow primitives.</a:t>
             </a:r>
             <a:endParaRPr lang="en-US" sz="1200" dirty="0"/>
           </a:p>
@@ -11619,7 +12814,7 @@
                 <a:ea typeface="Calibri" pitchFamily="34" charset="-122"/>
                 <a:cs typeface="Calibri" pitchFamily="34" charset="-120"/>
               </a:rPr>
-              <a:t>≈ 3-4 days</a:t>
+              <a:t>≈ 0.4 day</a:t>
             </a:r>
             <a:endParaRPr lang="en-US" sz="1100" dirty="0"/>
           </a:p>
@@ -11781,7 +12976,7 @@
                 <a:ea typeface="Calibri" pitchFamily="34" charset="-122"/>
                 <a:cs typeface="Calibri" pitchFamily="34" charset="-120"/>
               </a:rPr>
-              <a:t>Garden tab restructured to match web's plot layout. Horizontal-scrolling plot rows; user plot management.</a:t>
+              <a:t>Garden tab restructured to match web: horizontal-scrolling plot rows (LazyRow within LazyColumn). User plot management mirroring web.</a:t>
             </a:r>
             <a:endParaRPr lang="en-US" sz="1200" dirty="0"/>
           </a:p>
@@ -11820,7 +13015,7 @@
                 <a:ea typeface="Calibri" pitchFamily="34" charset="-122"/>
                 <a:cs typeface="Calibri" pitchFamily="34" charset="-120"/>
               </a:rPr>
-              <a:t>≈ 4-5 days</a:t>
+              <a:t>≈ 0.4 day</a:t>
             </a:r>
             <a:endParaRPr lang="en-US" sz="1100" dirty="0"/>
           </a:p>
@@ -11982,7 +13177,7 @@
                 <a:ea typeface="Calibri" pitchFamily="34" charset="-122"/>
                 <a:cs typeface="Calibri" pitchFamily="34" charset="-120"/>
               </a:rPr>
-              <a:t>Settings moves out of bottom nav into a burger menu. Bottom nav becomes Garden / Explore / Capsules. Three tabs, cleaner.</a:t>
+              <a:t>Settings moves out of bottom nav into a burger menu. Bottom nav becomes Garden / Explore / Capsules. Three tabs, cleaner, brand-quiet.</a:t>
             </a:r>
             <a:endParaRPr lang="en-US" sz="1200" dirty="0"/>
           </a:p>
@@ -12021,7 +13216,7 @@
                 <a:ea typeface="Calibri" pitchFamily="34" charset="-122"/>
                 <a:cs typeface="Calibri" pitchFamily="34" charset="-120"/>
               </a:rPr>
-              <a:t>≈ 1-2 days</a:t>
+              <a:t>≈ 0.2 day</a:t>
             </a:r>
             <a:endParaRPr lang="en-US" sz="1100" dirty="0"/>
           </a:p>
@@ -12060,7 +13255,7 @@
                 <a:ea typeface="Calibri" pitchFamily="34" charset="-122"/>
                 <a:cs typeface="Calibri" pitchFamily="34" charset="-120"/>
               </a:rPr>
-              <a:t>Stream: Android  ·  Cadence: 3 increments, each independently shippable</a:t>
+              <a:t>Three sub-tasks · Shipped as one focused session</a:t>
             </a:r>
             <a:endParaRPr lang="en-US" sz="1100" dirty="0"/>
           </a:p>

</xml_diff>